<commit_message>
Revert "Merge pull request #9 from jonathanvvelasco/Households_save"
This reverts commit 3ccbc976e63caf525348edf17be2f0b92e054b93, reversing
changes made to 2ab4d8c266078890fdaa82a8b77ef4fe2a02dcca.
</commit_message>
<xml_diff>
--- a/Documentação/1-Diagrama PPT/Cadeias Energéticas.pptx
+++ b/Documentação/1-Diagrama PPT/Cadeias Energéticas.pptx
@@ -5,13 +5,12 @@
     <p:sldMasterId id="2147483648" r:id="rId1"/>
   </p:sldMasterIdLst>
   <p:notesMasterIdLst>
-    <p:notesMasterId r:id="rId6"/>
+    <p:notesMasterId r:id="rId5"/>
   </p:notesMasterIdLst>
   <p:sldIdLst>
     <p:sldId id="260" r:id="rId2"/>
     <p:sldId id="259" r:id="rId3"/>
     <p:sldId id="261" r:id="rId4"/>
-    <p:sldId id="262" r:id="rId5"/>
   </p:sldIdLst>
   <p:sldSz cx="12192000" cy="6858000"/>
   <p:notesSz cx="6858000" cy="9144000"/>
@@ -211,7 +210,7 @@
           <a:p>
             <a:fld id="{F22EC251-D700-40B5-87D9-A45C9416D694}" type="datetimeFigureOut">
               <a:rPr lang="pt-BR" smtClean="0"/>
-              <a:t>02/11/2024</a:t>
+              <a:t>30/10/2024</a:t>
             </a:fld>
             <a:endParaRPr lang="pt-BR"/>
           </a:p>
@@ -749,117 +748,6 @@
 </p:notes>
 </file>
 
-<file path=ppt/notesSlides/notesSlide4.xml><?xml version="1.0" encoding="utf-8"?>
-<p:notes xmlns:a="http://schemas.openxmlformats.org/drawingml/2006/main" xmlns:r="http://schemas.openxmlformats.org/officeDocument/2006/relationships" xmlns:p="http://schemas.openxmlformats.org/presentationml/2006/main">
-  <p:cSld>
-    <p:spTree>
-      <p:nvGrpSpPr>
-        <p:cNvPr id="1" name="">
-          <a:extLst>
-            <a:ext uri="{FF2B5EF4-FFF2-40B4-BE49-F238E27FC236}">
-              <a16:creationId xmlns:a16="http://schemas.microsoft.com/office/drawing/2014/main" id="{C6D66CC4-B978-A1FE-0B29-044A341ADECA}"/>
-            </a:ext>
-          </a:extLst>
-        </p:cNvPr>
-        <p:cNvGrpSpPr/>
-        <p:nvPr/>
-      </p:nvGrpSpPr>
-      <p:grpSpPr>
-        <a:xfrm>
-          <a:off x="0" y="0"/>
-          <a:ext cx="0" cy="0"/>
-          <a:chOff x="0" y="0"/>
-          <a:chExt cx="0" cy="0"/>
-        </a:xfrm>
-      </p:grpSpPr>
-      <p:sp>
-        <p:nvSpPr>
-          <p:cNvPr id="2" name="Espaço Reservado para Imagem de Slide 1">
-            <a:extLst>
-              <a:ext uri="{FF2B5EF4-FFF2-40B4-BE49-F238E27FC236}">
-                <a16:creationId xmlns:a16="http://schemas.microsoft.com/office/drawing/2014/main" id="{0DA64698-487D-7511-214F-531435E377CC}"/>
-              </a:ext>
-            </a:extLst>
-          </p:cNvPr>
-          <p:cNvSpPr>
-            <a:spLocks noGrp="1" noRot="1" noChangeAspect="1"/>
-          </p:cNvSpPr>
-          <p:nvPr>
-            <p:ph type="sldImg"/>
-          </p:nvPr>
-        </p:nvSpPr>
-        <p:spPr/>
-      </p:sp>
-      <p:sp>
-        <p:nvSpPr>
-          <p:cNvPr id="3" name="Espaço Reservado para Anotações 2">
-            <a:extLst>
-              <a:ext uri="{FF2B5EF4-FFF2-40B4-BE49-F238E27FC236}">
-                <a16:creationId xmlns:a16="http://schemas.microsoft.com/office/drawing/2014/main" id="{3E5B77CE-6B03-593C-D065-E2BAD3B86032}"/>
-              </a:ext>
-            </a:extLst>
-          </p:cNvPr>
-          <p:cNvSpPr>
-            <a:spLocks noGrp="1"/>
-          </p:cNvSpPr>
-          <p:nvPr>
-            <p:ph type="body" idx="1"/>
-          </p:nvPr>
-        </p:nvSpPr>
-        <p:spPr/>
-        <p:txBody>
-          <a:bodyPr/>
-          <a:lstStyle/>
-          <a:p>
-            <a:r>
-              <a:rPr lang="pt-BR" dirty="0"/>
-              <a:t>Tentativa como Energia Final</a:t>
-            </a:r>
-          </a:p>
-        </p:txBody>
-      </p:sp>
-      <p:sp>
-        <p:nvSpPr>
-          <p:cNvPr id="4" name="Espaço Reservado para Número de Slide 3">
-            <a:extLst>
-              <a:ext uri="{FF2B5EF4-FFF2-40B4-BE49-F238E27FC236}">
-                <a16:creationId xmlns:a16="http://schemas.microsoft.com/office/drawing/2014/main" id="{4158D553-3492-6CAF-73FE-B11340BCD192}"/>
-              </a:ext>
-            </a:extLst>
-          </p:cNvPr>
-          <p:cNvSpPr>
-            <a:spLocks noGrp="1"/>
-          </p:cNvSpPr>
-          <p:nvPr>
-            <p:ph type="sldNum" sz="quarter" idx="5"/>
-          </p:nvPr>
-        </p:nvSpPr>
-        <p:spPr/>
-        <p:txBody>
-          <a:bodyPr/>
-          <a:lstStyle/>
-          <a:p>
-            <a:fld id="{04C3BA9C-038C-4BB8-B038-C189F78C736F}" type="slidenum">
-              <a:rPr lang="pt-BR" smtClean="0"/>
-              <a:t>4</a:t>
-            </a:fld>
-            <a:endParaRPr lang="pt-BR"/>
-          </a:p>
-        </p:txBody>
-      </p:sp>
-    </p:spTree>
-    <p:extLst>
-      <p:ext uri="{BB962C8B-B14F-4D97-AF65-F5344CB8AC3E}">
-        <p14:creationId xmlns:p14="http://schemas.microsoft.com/office/powerpoint/2010/main" val="1769664969"/>
-      </p:ext>
-    </p:extLst>
-  </p:cSld>
-  <p:clrMapOvr>
-    <a:masterClrMapping/>
-  </p:clrMapOvr>
-</p:notes>
-</file>
-
 <file path=ppt/slideLayouts/slideLayout1.xml><?xml version="1.0" encoding="utf-8"?>
 <p:sldLayout xmlns:a="http://schemas.openxmlformats.org/drawingml/2006/main" xmlns:r="http://schemas.openxmlformats.org/officeDocument/2006/relationships" xmlns:p="http://schemas.openxmlformats.org/presentationml/2006/main" type="title" preserve="1">
   <p:cSld name="Slide de título">
@@ -1040,7 +928,7 @@
             <a:fld id="{C11B6B41-91B8-4293-9633-874C21C369B6}" type="datetimeFigureOut">
               <a:rPr lang="pt-BR" smtClean="0"/>
               <a:pPr/>
-              <a:t>02/11/2024</a:t>
+              <a:t>30/10/2024</a:t>
             </a:fld>
             <a:endParaRPr lang="pt-BR"/>
           </a:p>
@@ -1205,7 +1093,7 @@
             <a:fld id="{C11B6B41-91B8-4293-9633-874C21C369B6}" type="datetimeFigureOut">
               <a:rPr lang="pt-BR" smtClean="0"/>
               <a:pPr/>
-              <a:t>02/11/2024</a:t>
+              <a:t>30/10/2024</a:t>
             </a:fld>
             <a:endParaRPr lang="pt-BR"/>
           </a:p>
@@ -1380,7 +1268,7 @@
             <a:fld id="{C11B6B41-91B8-4293-9633-874C21C369B6}" type="datetimeFigureOut">
               <a:rPr lang="pt-BR" smtClean="0"/>
               <a:pPr/>
-              <a:t>02/11/2024</a:t>
+              <a:t>30/10/2024</a:t>
             </a:fld>
             <a:endParaRPr lang="pt-BR"/>
           </a:p>
@@ -1545,7 +1433,7 @@
             <a:fld id="{C11B6B41-91B8-4293-9633-874C21C369B6}" type="datetimeFigureOut">
               <a:rPr lang="pt-BR" smtClean="0"/>
               <a:pPr/>
-              <a:t>02/11/2024</a:t>
+              <a:t>30/10/2024</a:t>
             </a:fld>
             <a:endParaRPr lang="pt-BR"/>
           </a:p>
@@ -1787,7 +1675,7 @@
             <a:fld id="{C11B6B41-91B8-4293-9633-874C21C369B6}" type="datetimeFigureOut">
               <a:rPr lang="pt-BR" smtClean="0"/>
               <a:pPr/>
-              <a:t>02/11/2024</a:t>
+              <a:t>30/10/2024</a:t>
             </a:fld>
             <a:endParaRPr lang="pt-BR"/>
           </a:p>
@@ -2069,7 +1957,7 @@
             <a:fld id="{C11B6B41-91B8-4293-9633-874C21C369B6}" type="datetimeFigureOut">
               <a:rPr lang="pt-BR" smtClean="0"/>
               <a:pPr/>
-              <a:t>02/11/2024</a:t>
+              <a:t>30/10/2024</a:t>
             </a:fld>
             <a:endParaRPr lang="pt-BR"/>
           </a:p>
@@ -2485,7 +2373,7 @@
             <a:fld id="{C11B6B41-91B8-4293-9633-874C21C369B6}" type="datetimeFigureOut">
               <a:rPr lang="pt-BR" smtClean="0"/>
               <a:pPr/>
-              <a:t>02/11/2024</a:t>
+              <a:t>30/10/2024</a:t>
             </a:fld>
             <a:endParaRPr lang="pt-BR"/>
           </a:p>
@@ -2599,7 +2487,7 @@
             <a:fld id="{C11B6B41-91B8-4293-9633-874C21C369B6}" type="datetimeFigureOut">
               <a:rPr lang="pt-BR" smtClean="0"/>
               <a:pPr/>
-              <a:t>02/11/2024</a:t>
+              <a:t>30/10/2024</a:t>
             </a:fld>
             <a:endParaRPr lang="pt-BR"/>
           </a:p>
@@ -2691,7 +2579,7 @@
             <a:fld id="{C11B6B41-91B8-4293-9633-874C21C369B6}" type="datetimeFigureOut">
               <a:rPr lang="pt-BR" smtClean="0"/>
               <a:pPr/>
-              <a:t>02/11/2024</a:t>
+              <a:t>30/10/2024</a:t>
             </a:fld>
             <a:endParaRPr lang="pt-BR"/>
           </a:p>
@@ -2963,7 +2851,7 @@
             <a:fld id="{C11B6B41-91B8-4293-9633-874C21C369B6}" type="datetimeFigureOut">
               <a:rPr lang="pt-BR" smtClean="0"/>
               <a:pPr/>
-              <a:t>02/11/2024</a:t>
+              <a:t>30/10/2024</a:t>
             </a:fld>
             <a:endParaRPr lang="pt-BR"/>
           </a:p>
@@ -3212,7 +3100,7 @@
             <a:fld id="{C11B6B41-91B8-4293-9633-874C21C369B6}" type="datetimeFigureOut">
               <a:rPr lang="pt-BR" smtClean="0"/>
               <a:pPr/>
-              <a:t>02/11/2024</a:t>
+              <a:t>30/10/2024</a:t>
             </a:fld>
             <a:endParaRPr lang="pt-BR"/>
           </a:p>
@@ -3420,7 +3308,7 @@
             <a:fld id="{C11B6B41-91B8-4293-9633-874C21C369B6}" type="datetimeFigureOut">
               <a:rPr lang="pt-BR" smtClean="0"/>
               <a:pPr/>
-              <a:t>02/11/2024</a:t>
+              <a:t>30/10/2024</a:t>
             </a:fld>
             <a:endParaRPr lang="pt-BR"/>
           </a:p>
@@ -7422,7 +7310,7 @@
         </p:nvSpPr>
         <p:spPr>
           <a:xfrm>
-            <a:off x="2277971" y="2147776"/>
+            <a:off x="2770671" y="2158409"/>
             <a:ext cx="1167812" cy="648098"/>
           </a:xfrm>
           <a:prstGeom prst="roundRect">
@@ -7517,7 +7405,7 @@
         </p:nvSpPr>
         <p:spPr>
           <a:xfrm>
-            <a:off x="2277971" y="3012636"/>
+            <a:off x="2770671" y="3023269"/>
             <a:ext cx="1167812" cy="648098"/>
           </a:xfrm>
           <a:prstGeom prst="roundRect">
@@ -7614,7 +7502,7 @@
         </p:nvCxnSpPr>
         <p:spPr>
           <a:xfrm>
-            <a:off x="3934872" y="1414130"/>
+            <a:off x="4427572" y="1424763"/>
             <a:ext cx="0" cy="4848446"/>
           </a:xfrm>
           <a:prstGeom prst="line">
@@ -7645,7 +7533,7 @@
         </p:nvSpPr>
         <p:spPr>
           <a:xfrm rot="16200000">
-            <a:off x="3105536" y="5370285"/>
+            <a:off x="3598236" y="5380918"/>
             <a:ext cx="1446028" cy="338554"/>
           </a:xfrm>
           <a:prstGeom prst="rect">
@@ -7720,7 +7608,7 @@
         </p:nvCxnSpPr>
         <p:spPr>
           <a:xfrm>
-            <a:off x="3456416" y="2452654"/>
+            <a:off x="3949116" y="2463287"/>
             <a:ext cx="490860" cy="0"/>
           </a:xfrm>
           <a:prstGeom prst="straightConnector1">
@@ -8159,7 +8047,7 @@
         </p:nvCxnSpPr>
         <p:spPr>
           <a:xfrm>
-            <a:off x="3445783" y="3377608"/>
+            <a:off x="3938483" y="3388241"/>
             <a:ext cx="490860" cy="0"/>
           </a:xfrm>
           <a:prstGeom prst="straightConnector1">
@@ -8193,8 +8081,8 @@
         </p:nvCxnSpPr>
         <p:spPr>
           <a:xfrm>
-            <a:off x="3947276" y="3023269"/>
-            <a:ext cx="983560" cy="0"/>
+            <a:off x="4439976" y="3023269"/>
+            <a:ext cx="490860" cy="0"/>
           </a:xfrm>
           <a:prstGeom prst="straightConnector1">
             <a:avLst/>
@@ -9023,7 +8911,7 @@
         </p:nvSpPr>
         <p:spPr>
           <a:xfrm rot="5400000">
-            <a:off x="2733463" y="3726944"/>
+            <a:off x="3226163" y="3737577"/>
             <a:ext cx="458780" cy="523220"/>
           </a:xfrm>
           <a:prstGeom prst="rect">
@@ -9058,7 +8946,7 @@
         </p:nvSpPr>
         <p:spPr>
           <a:xfrm>
-            <a:off x="2264022" y="4307395"/>
+            <a:off x="2756722" y="4318028"/>
             <a:ext cx="1167812" cy="648098"/>
           </a:xfrm>
           <a:prstGeom prst="roundRect">
@@ -9155,7 +9043,7 @@
         </p:nvCxnSpPr>
         <p:spPr>
           <a:xfrm>
-            <a:off x="3442467" y="4612273"/>
+            <a:off x="3935167" y="4622906"/>
             <a:ext cx="490860" cy="0"/>
           </a:xfrm>
           <a:prstGeom prst="straightConnector1">
@@ -9177,2850 +9065,6 @@
     <p:extLst>
       <p:ext uri="{BB962C8B-B14F-4D97-AF65-F5344CB8AC3E}">
         <p14:creationId xmlns:p14="http://schemas.microsoft.com/office/powerpoint/2010/main" val="3156359377"/>
-      </p:ext>
-    </p:extLst>
-  </p:cSld>
-  <p:clrMapOvr>
-    <a:masterClrMapping/>
-  </p:clrMapOvr>
-</p:sld>
-</file>
-
-<file path=ppt/slides/slide4.xml><?xml version="1.0" encoding="utf-8"?>
-<p:sld xmlns:a="http://schemas.openxmlformats.org/drawingml/2006/main" xmlns:r="http://schemas.openxmlformats.org/officeDocument/2006/relationships" xmlns:p="http://schemas.openxmlformats.org/presentationml/2006/main">
-  <p:cSld>
-    <p:spTree>
-      <p:nvGrpSpPr>
-        <p:cNvPr id="1" name="">
-          <a:extLst>
-            <a:ext uri="{FF2B5EF4-FFF2-40B4-BE49-F238E27FC236}">
-              <a16:creationId xmlns:a16="http://schemas.microsoft.com/office/drawing/2014/main" id="{BD819B1A-4A56-833E-22C6-713DB935895C}"/>
-            </a:ext>
-          </a:extLst>
-        </p:cNvPr>
-        <p:cNvGrpSpPr/>
-        <p:nvPr/>
-      </p:nvGrpSpPr>
-      <p:grpSpPr>
-        <a:xfrm>
-          <a:off x="0" y="0"/>
-          <a:ext cx="0" cy="0"/>
-          <a:chOff x="0" y="0"/>
-          <a:chExt cx="0" cy="0"/>
-        </a:xfrm>
-      </p:grpSpPr>
-      <p:pic>
-        <p:nvPicPr>
-          <p:cNvPr id="82" name="Picture 4">
-            <a:extLst>
-              <a:ext uri="{FF2B5EF4-FFF2-40B4-BE49-F238E27FC236}">
-                <a16:creationId xmlns:a16="http://schemas.microsoft.com/office/drawing/2014/main" id="{6491C1BA-2133-11E9-3E3E-CFC073F3ADEF}"/>
-              </a:ext>
-            </a:extLst>
-          </p:cNvPr>
-          <p:cNvPicPr>
-            <a:picLocks noChangeAspect="1"/>
-          </p:cNvPicPr>
-          <p:nvPr/>
-        </p:nvPicPr>
-        <p:blipFill>
-          <a:blip r:embed="rId3">
-            <a:extLst>
-              <a:ext uri="{28A0092B-C50C-407E-A947-70E740481C1C}">
-                <a14:useLocalDpi xmlns:a14="http://schemas.microsoft.com/office/drawing/2010/main" val="0"/>
-              </a:ext>
-            </a:extLst>
-          </a:blip>
-          <a:srcRect l="43433" r="2365" b="6209"/>
-          <a:stretch/>
-        </p:blipFill>
-        <p:spPr>
-          <a:xfrm>
-            <a:off x="80282" y="103706"/>
-            <a:ext cx="1748518" cy="6637661"/>
-          </a:xfrm>
-          <a:prstGeom prst="rect">
-            <a:avLst/>
-          </a:prstGeom>
-        </p:spPr>
-      </p:pic>
-      <p:sp>
-        <p:nvSpPr>
-          <p:cNvPr id="83" name="Rectangle: Rounded Corners 5">
-            <a:extLst>
-              <a:ext uri="{FF2B5EF4-FFF2-40B4-BE49-F238E27FC236}">
-                <a16:creationId xmlns:a16="http://schemas.microsoft.com/office/drawing/2014/main" id="{D798218F-06E9-0CC0-93C3-E21D05F3A20B}"/>
-              </a:ext>
-            </a:extLst>
-          </p:cNvPr>
-          <p:cNvSpPr/>
-          <p:nvPr/>
-        </p:nvSpPr>
-        <p:spPr>
-          <a:xfrm>
-            <a:off x="2277971" y="2147776"/>
-            <a:ext cx="1167812" cy="648098"/>
-          </a:xfrm>
-          <a:prstGeom prst="roundRect">
-            <a:avLst/>
-          </a:prstGeom>
-          <a:solidFill>
-            <a:srgbClr val="4472C4"/>
-          </a:solidFill>
-          <a:ln w="12700" cap="flat" cmpd="sng" algn="ctr">
-            <a:solidFill>
-              <a:srgbClr val="4472C4">
-                <a:shade val="50000"/>
-              </a:srgbClr>
-            </a:solidFill>
-            <a:prstDash val="solid"/>
-            <a:miter lim="800000"/>
-          </a:ln>
-          <a:effectLst>
-            <a:outerShdw blurRad="50800" dist="38100" dir="2700000" algn="tl" rotWithShape="0">
-              <a:prstClr val="black">
-                <a:alpha val="40000"/>
-              </a:prstClr>
-            </a:outerShdw>
-          </a:effectLst>
-        </p:spPr>
-        <p:txBody>
-          <a:bodyPr rtlCol="0" anchor="ctr"/>
-          <a:lstStyle/>
-          <a:p>
-            <a:pPr marL="0" marR="0" lvl="0" indent="0" algn="ctr" defTabSz="914400" eaLnBrk="1" fontAlgn="auto" latinLnBrk="0" hangingPunct="1">
-              <a:lnSpc>
-                <a:spcPct val="100000"/>
-              </a:lnSpc>
-              <a:spcBef>
-                <a:spcPts val="0"/>
-              </a:spcBef>
-              <a:spcAft>
-                <a:spcPts val="0"/>
-              </a:spcAft>
-              <a:buClrTx/>
-              <a:buSzTx/>
-              <a:buFontTx/>
-              <a:buNone/>
-              <a:tabLst/>
-              <a:defRPr/>
-            </a:pPr>
-            <a:r>
-              <a:rPr kumimoji="0" lang="en-US" sz="1400" b="0" i="0" u="none" strike="noStrike" kern="0" cap="none" spc="0" normalizeH="0" baseline="0" noProof="0" dirty="0">
-                <a:ln>
-                  <a:noFill/>
-                </a:ln>
-                <a:solidFill>
-                  <a:prstClr val="white"/>
-                </a:solidFill>
-                <a:effectLst/>
-                <a:uLnTx/>
-                <a:uFillTx/>
-                <a:latin typeface="Calibri" panose="020F0502020204030204"/>
-                <a:ea typeface="+mn-ea"/>
-                <a:cs typeface="+mn-cs"/>
-              </a:rPr>
-              <a:t>Hydro Power plant</a:t>
-            </a:r>
-            <a:endParaRPr kumimoji="0" lang="en-GB" sz="1400" b="0" i="0" u="none" strike="noStrike" kern="0" cap="none" spc="0" normalizeH="0" baseline="0" noProof="0" dirty="0">
-              <a:ln>
-                <a:noFill/>
-              </a:ln>
-              <a:solidFill>
-                <a:prstClr val="white"/>
-              </a:solidFill>
-              <a:effectLst/>
-              <a:uLnTx/>
-              <a:uFillTx/>
-              <a:latin typeface="Calibri" panose="020F0502020204030204"/>
-              <a:ea typeface="+mn-ea"/>
-              <a:cs typeface="+mn-cs"/>
-            </a:endParaRPr>
-          </a:p>
-        </p:txBody>
-      </p:sp>
-      <p:sp>
-        <p:nvSpPr>
-          <p:cNvPr id="84" name="Rectangle: Rounded Corners 7">
-            <a:extLst>
-              <a:ext uri="{FF2B5EF4-FFF2-40B4-BE49-F238E27FC236}">
-                <a16:creationId xmlns:a16="http://schemas.microsoft.com/office/drawing/2014/main" id="{5EF5CD24-B112-6832-AAA6-41F20460BF0D}"/>
-              </a:ext>
-            </a:extLst>
-          </p:cNvPr>
-          <p:cNvSpPr/>
-          <p:nvPr/>
-        </p:nvSpPr>
-        <p:spPr>
-          <a:xfrm>
-            <a:off x="2277971" y="3012636"/>
-            <a:ext cx="1167812" cy="648098"/>
-          </a:xfrm>
-          <a:prstGeom prst="roundRect">
-            <a:avLst/>
-          </a:prstGeom>
-          <a:solidFill>
-            <a:srgbClr val="4472C4"/>
-          </a:solidFill>
-          <a:ln w="12700" cap="flat" cmpd="sng" algn="ctr">
-            <a:solidFill>
-              <a:srgbClr val="4472C4">
-                <a:shade val="50000"/>
-              </a:srgbClr>
-            </a:solidFill>
-            <a:prstDash val="solid"/>
-            <a:miter lim="800000"/>
-          </a:ln>
-          <a:effectLst>
-            <a:outerShdw blurRad="50800" dist="38100" dir="2700000" algn="tl" rotWithShape="0">
-              <a:prstClr val="black">
-                <a:alpha val="40000"/>
-              </a:prstClr>
-            </a:outerShdw>
-          </a:effectLst>
-        </p:spPr>
-        <p:txBody>
-          <a:bodyPr rtlCol="0" anchor="ctr"/>
-          <a:lstStyle/>
-          <a:p>
-            <a:pPr marL="0" marR="0" lvl="0" indent="0" algn="ctr" defTabSz="914400" eaLnBrk="1" fontAlgn="auto" latinLnBrk="0" hangingPunct="1">
-              <a:lnSpc>
-                <a:spcPct val="100000"/>
-              </a:lnSpc>
-              <a:spcBef>
-                <a:spcPts val="0"/>
-              </a:spcBef>
-              <a:spcAft>
-                <a:spcPts val="0"/>
-              </a:spcAft>
-              <a:buClrTx/>
-              <a:buSzTx/>
-              <a:buFontTx/>
-              <a:buNone/>
-              <a:tabLst/>
-              <a:defRPr/>
-            </a:pPr>
-            <a:r>
-              <a:rPr kumimoji="0" lang="en-US" sz="1400" b="0" i="0" u="none" strike="noStrike" kern="0" cap="none" spc="0" normalizeH="0" baseline="0" noProof="0" dirty="0">
-                <a:ln>
-                  <a:noFill/>
-                </a:ln>
-                <a:solidFill>
-                  <a:prstClr val="white"/>
-                </a:solidFill>
-                <a:effectLst/>
-                <a:uLnTx/>
-                <a:uFillTx/>
-                <a:latin typeface="Calibri" panose="020F0502020204030204"/>
-                <a:ea typeface="+mn-ea"/>
-                <a:cs typeface="+mn-cs"/>
-              </a:rPr>
-              <a:t>Wind Power plant</a:t>
-            </a:r>
-            <a:endParaRPr kumimoji="0" lang="en-GB" sz="1400" b="0" i="0" u="none" strike="noStrike" kern="0" cap="none" spc="0" normalizeH="0" baseline="0" noProof="0" dirty="0">
-              <a:ln>
-                <a:noFill/>
-              </a:ln>
-              <a:solidFill>
-                <a:prstClr val="white"/>
-              </a:solidFill>
-              <a:effectLst/>
-              <a:uLnTx/>
-              <a:uFillTx/>
-              <a:latin typeface="Calibri" panose="020F0502020204030204"/>
-              <a:ea typeface="+mn-ea"/>
-              <a:cs typeface="+mn-cs"/>
-            </a:endParaRPr>
-          </a:p>
-        </p:txBody>
-      </p:sp>
-      <p:cxnSp>
-        <p:nvCxnSpPr>
-          <p:cNvPr id="85" name="Straight Connector 9">
-            <a:extLst>
-              <a:ext uri="{FF2B5EF4-FFF2-40B4-BE49-F238E27FC236}">
-                <a16:creationId xmlns:a16="http://schemas.microsoft.com/office/drawing/2014/main" id="{B9958F4D-40D5-F300-1161-598EFC046A11}"/>
-              </a:ext>
-            </a:extLst>
-          </p:cNvPr>
-          <p:cNvCxnSpPr>
-            <a:cxnSpLocks/>
-          </p:cNvCxnSpPr>
-          <p:nvPr/>
-        </p:nvCxnSpPr>
-        <p:spPr>
-          <a:xfrm>
-            <a:off x="3934872" y="1414130"/>
-            <a:ext cx="0" cy="4848446"/>
-          </a:xfrm>
-          <a:prstGeom prst="line">
-            <a:avLst/>
-          </a:prstGeom>
-          <a:noFill/>
-          <a:ln w="19050" cap="flat" cmpd="sng" algn="ctr">
-            <a:solidFill>
-              <a:srgbClr val="A5A5A5"/>
-            </a:solidFill>
-            <a:prstDash val="solid"/>
-            <a:miter lim="800000"/>
-          </a:ln>
-          <a:effectLst/>
-        </p:spPr>
-      </p:cxnSp>
-      <p:sp>
-        <p:nvSpPr>
-          <p:cNvPr id="86" name="TextBox 11">
-            <a:extLst>
-              <a:ext uri="{FF2B5EF4-FFF2-40B4-BE49-F238E27FC236}">
-                <a16:creationId xmlns:a16="http://schemas.microsoft.com/office/drawing/2014/main" id="{CA290027-3AA1-02A7-A01A-A916AD6B1F07}"/>
-              </a:ext>
-            </a:extLst>
-          </p:cNvPr>
-          <p:cNvSpPr txBox="1"/>
-          <p:nvPr/>
-        </p:nvSpPr>
-        <p:spPr>
-          <a:xfrm rot="16200000">
-            <a:off x="3105536" y="5370285"/>
-            <a:ext cx="1446028" cy="338554"/>
-          </a:xfrm>
-          <a:prstGeom prst="rect">
-            <a:avLst/>
-          </a:prstGeom>
-          <a:noFill/>
-        </p:spPr>
-        <p:txBody>
-          <a:bodyPr wrap="square" rtlCol="0">
-            <a:spAutoFit/>
-          </a:bodyPr>
-          <a:lstStyle/>
-          <a:p>
-            <a:pPr marL="0" marR="0" lvl="0" indent="0" defTabSz="914400" eaLnBrk="1" fontAlgn="auto" latinLnBrk="0" hangingPunct="1">
-              <a:lnSpc>
-                <a:spcPct val="100000"/>
-              </a:lnSpc>
-              <a:spcBef>
-                <a:spcPts val="0"/>
-              </a:spcBef>
-              <a:spcAft>
-                <a:spcPts val="0"/>
-              </a:spcAft>
-              <a:buClrTx/>
-              <a:buSzTx/>
-              <a:buFontTx/>
-              <a:buNone/>
-              <a:tabLst/>
-              <a:defRPr/>
-            </a:pPr>
-            <a:r>
-              <a:rPr kumimoji="0" lang="en-US" sz="1600" b="0" i="1" u="none" strike="noStrike" kern="0" cap="none" spc="0" normalizeH="0" baseline="0" noProof="0" dirty="0">
-                <a:ln>
-                  <a:noFill/>
-                </a:ln>
-                <a:solidFill>
-                  <a:prstClr val="black"/>
-                </a:solidFill>
-                <a:effectLst/>
-                <a:uLnTx/>
-                <a:uFillTx/>
-              </a:rPr>
-              <a:t>electricity</a:t>
-            </a:r>
-            <a:endParaRPr kumimoji="0" lang="en-GB" sz="1600" b="0" i="1" u="none" strike="noStrike" kern="0" cap="none" spc="0" normalizeH="0" baseline="0" noProof="0" dirty="0">
-              <a:ln>
-                <a:noFill/>
-              </a:ln>
-              <a:solidFill>
-                <a:prstClr val="black"/>
-              </a:solidFill>
-              <a:effectLst/>
-              <a:uLnTx/>
-              <a:uFillTx/>
-            </a:endParaRPr>
-          </a:p>
-        </p:txBody>
-      </p:sp>
-      <p:cxnSp>
-        <p:nvCxnSpPr>
-          <p:cNvPr id="87" name="Straight Arrow Connector 18">
-            <a:extLst>
-              <a:ext uri="{FF2B5EF4-FFF2-40B4-BE49-F238E27FC236}">
-                <a16:creationId xmlns:a16="http://schemas.microsoft.com/office/drawing/2014/main" id="{8F18217B-C9B4-2A51-DD64-EA54DE743CAE}"/>
-              </a:ext>
-            </a:extLst>
-          </p:cNvPr>
-          <p:cNvCxnSpPr>
-            <a:cxnSpLocks/>
-          </p:cNvCxnSpPr>
-          <p:nvPr/>
-        </p:nvCxnSpPr>
-        <p:spPr>
-          <a:xfrm>
-            <a:off x="3456416" y="2452654"/>
-            <a:ext cx="490860" cy="0"/>
-          </a:xfrm>
-          <a:prstGeom prst="straightConnector1">
-            <a:avLst/>
-          </a:prstGeom>
-          <a:noFill/>
-          <a:ln w="19050" cap="flat" cmpd="sng" algn="ctr">
-            <a:solidFill>
-              <a:srgbClr val="A5A5A5"/>
-            </a:solidFill>
-            <a:prstDash val="solid"/>
-            <a:miter lim="800000"/>
-            <a:tailEnd type="triangle"/>
-          </a:ln>
-          <a:effectLst/>
-        </p:spPr>
-      </p:cxnSp>
-      <p:sp>
-        <p:nvSpPr>
-          <p:cNvPr id="88" name="Rectangle: Rounded Corners 20">
-            <a:extLst>
-              <a:ext uri="{FF2B5EF4-FFF2-40B4-BE49-F238E27FC236}">
-                <a16:creationId xmlns:a16="http://schemas.microsoft.com/office/drawing/2014/main" id="{820E5F28-CA4B-7A9A-B7CB-A2435BCE0DF5}"/>
-              </a:ext>
-            </a:extLst>
-          </p:cNvPr>
-          <p:cNvSpPr/>
-          <p:nvPr/>
-        </p:nvSpPr>
-        <p:spPr>
-          <a:xfrm>
-            <a:off x="4928188" y="2701159"/>
-            <a:ext cx="1167812" cy="648098"/>
-          </a:xfrm>
-          <a:prstGeom prst="roundRect">
-            <a:avLst/>
-          </a:prstGeom>
-          <a:solidFill>
-            <a:srgbClr val="A5A5A5"/>
-          </a:solidFill>
-          <a:ln w="12700" cap="flat" cmpd="sng" algn="ctr">
-            <a:solidFill>
-              <a:srgbClr val="4472C4">
-                <a:shade val="50000"/>
-              </a:srgbClr>
-            </a:solidFill>
-            <a:prstDash val="solid"/>
-            <a:miter lim="800000"/>
-          </a:ln>
-          <a:effectLst>
-            <a:outerShdw blurRad="50800" dist="38100" dir="2700000" algn="tl" rotWithShape="0">
-              <a:prstClr val="black">
-                <a:alpha val="40000"/>
-              </a:prstClr>
-            </a:outerShdw>
-          </a:effectLst>
-        </p:spPr>
-        <p:txBody>
-          <a:bodyPr rtlCol="0" anchor="ctr"/>
-          <a:lstStyle/>
-          <a:p>
-            <a:pPr marL="0" marR="0" lvl="0" indent="0" algn="ctr" defTabSz="914400" eaLnBrk="1" fontAlgn="auto" latinLnBrk="0" hangingPunct="1">
-              <a:lnSpc>
-                <a:spcPct val="100000"/>
-              </a:lnSpc>
-              <a:spcBef>
-                <a:spcPts val="0"/>
-              </a:spcBef>
-              <a:spcAft>
-                <a:spcPts val="0"/>
-              </a:spcAft>
-              <a:buClrTx/>
-              <a:buSzTx/>
-              <a:buFontTx/>
-              <a:buNone/>
-              <a:tabLst/>
-              <a:defRPr/>
-            </a:pPr>
-            <a:r>
-              <a:rPr kumimoji="0" lang="en-US" sz="1400" b="0" i="0" u="none" strike="noStrike" kern="0" cap="none" spc="0" normalizeH="0" baseline="0" noProof="0" dirty="0">
-                <a:ln>
-                  <a:noFill/>
-                </a:ln>
-                <a:solidFill>
-                  <a:prstClr val="white"/>
-                </a:solidFill>
-                <a:effectLst/>
-                <a:uLnTx/>
-                <a:uFillTx/>
-                <a:latin typeface="Calibri" panose="020F0502020204030204"/>
-                <a:ea typeface="+mn-ea"/>
-                <a:cs typeface="+mn-cs"/>
-              </a:rPr>
-              <a:t>Electricity grid</a:t>
-            </a:r>
-            <a:endParaRPr kumimoji="0" lang="en-GB" sz="1400" b="0" i="0" u="none" strike="noStrike" kern="0" cap="none" spc="0" normalizeH="0" baseline="0" noProof="0" dirty="0">
-              <a:ln>
-                <a:noFill/>
-              </a:ln>
-              <a:solidFill>
-                <a:prstClr val="white"/>
-              </a:solidFill>
-              <a:effectLst/>
-              <a:uLnTx/>
-              <a:uFillTx/>
-              <a:latin typeface="Calibri" panose="020F0502020204030204"/>
-              <a:ea typeface="+mn-ea"/>
-              <a:cs typeface="+mn-cs"/>
-            </a:endParaRPr>
-          </a:p>
-        </p:txBody>
-      </p:sp>
-      <p:cxnSp>
-        <p:nvCxnSpPr>
-          <p:cNvPr id="89" name="Straight Connector 23">
-            <a:extLst>
-              <a:ext uri="{FF2B5EF4-FFF2-40B4-BE49-F238E27FC236}">
-                <a16:creationId xmlns:a16="http://schemas.microsoft.com/office/drawing/2014/main" id="{43742D25-D821-7B04-5415-5341C8EB3CB1}"/>
-              </a:ext>
-            </a:extLst>
-          </p:cNvPr>
-          <p:cNvCxnSpPr>
-            <a:cxnSpLocks/>
-          </p:cNvCxnSpPr>
-          <p:nvPr/>
-        </p:nvCxnSpPr>
-        <p:spPr>
-          <a:xfrm>
-            <a:off x="6574470" y="1414130"/>
-            <a:ext cx="0" cy="4848446"/>
-          </a:xfrm>
-          <a:prstGeom prst="line">
-            <a:avLst/>
-          </a:prstGeom>
-          <a:noFill/>
-          <a:ln w="19050" cap="flat" cmpd="sng" algn="ctr">
-            <a:solidFill>
-              <a:srgbClr val="A5A5A5"/>
-            </a:solidFill>
-            <a:prstDash val="solid"/>
-            <a:miter lim="800000"/>
-          </a:ln>
-          <a:effectLst/>
-        </p:spPr>
-      </p:cxnSp>
-      <p:sp>
-        <p:nvSpPr>
-          <p:cNvPr id="90" name="TextBox 24">
-            <a:extLst>
-              <a:ext uri="{FF2B5EF4-FFF2-40B4-BE49-F238E27FC236}">
-                <a16:creationId xmlns:a16="http://schemas.microsoft.com/office/drawing/2014/main" id="{F0071EEC-DCDB-1930-C33F-C17BED132447}"/>
-              </a:ext>
-            </a:extLst>
-          </p:cNvPr>
-          <p:cNvSpPr txBox="1"/>
-          <p:nvPr/>
-        </p:nvSpPr>
-        <p:spPr>
-          <a:xfrm rot="16200000">
-            <a:off x="5745134" y="5370285"/>
-            <a:ext cx="1446028" cy="338554"/>
-          </a:xfrm>
-          <a:prstGeom prst="rect">
-            <a:avLst/>
-          </a:prstGeom>
-          <a:noFill/>
-        </p:spPr>
-        <p:txBody>
-          <a:bodyPr wrap="square" rtlCol="0">
-            <a:spAutoFit/>
-          </a:bodyPr>
-          <a:lstStyle/>
-          <a:p>
-            <a:pPr marL="0" marR="0" lvl="0" indent="0" defTabSz="914400" eaLnBrk="1" fontAlgn="auto" latinLnBrk="0" hangingPunct="1">
-              <a:lnSpc>
-                <a:spcPct val="100000"/>
-              </a:lnSpc>
-              <a:spcBef>
-                <a:spcPts val="0"/>
-              </a:spcBef>
-              <a:spcAft>
-                <a:spcPts val="0"/>
-              </a:spcAft>
-              <a:buClrTx/>
-              <a:buSzTx/>
-              <a:buFontTx/>
-              <a:buNone/>
-              <a:tabLst/>
-              <a:defRPr/>
-            </a:pPr>
-            <a:r>
-              <a:rPr kumimoji="0" lang="en-US" sz="1600" b="0" i="1" u="none" strike="noStrike" kern="0" cap="none" spc="0" normalizeH="0" baseline="0" noProof="0" dirty="0">
-                <a:ln>
-                  <a:noFill/>
-                </a:ln>
-                <a:solidFill>
-                  <a:prstClr val="black"/>
-                </a:solidFill>
-                <a:effectLst/>
-                <a:uLnTx/>
-                <a:uFillTx/>
-              </a:rPr>
-              <a:t>electricity</a:t>
-            </a:r>
-            <a:endParaRPr kumimoji="0" lang="en-GB" sz="1600" b="0" i="1" u="none" strike="noStrike" kern="0" cap="none" spc="0" normalizeH="0" baseline="0" noProof="0" dirty="0">
-              <a:ln>
-                <a:noFill/>
-              </a:ln>
-              <a:solidFill>
-                <a:prstClr val="black"/>
-              </a:solidFill>
-              <a:effectLst/>
-              <a:uLnTx/>
-              <a:uFillTx/>
-            </a:endParaRPr>
-          </a:p>
-        </p:txBody>
-      </p:sp>
-      <p:sp>
-        <p:nvSpPr>
-          <p:cNvPr id="91" name="Rectangle: Rounded Corners 26">
-            <a:extLst>
-              <a:ext uri="{FF2B5EF4-FFF2-40B4-BE49-F238E27FC236}">
-                <a16:creationId xmlns:a16="http://schemas.microsoft.com/office/drawing/2014/main" id="{CA491A71-0D6A-CC44-FB0A-32859D85FE14}"/>
-              </a:ext>
-            </a:extLst>
-          </p:cNvPr>
-          <p:cNvSpPr/>
-          <p:nvPr/>
-        </p:nvSpPr>
-        <p:spPr>
-          <a:xfrm>
-            <a:off x="7079476" y="2699220"/>
-            <a:ext cx="1167812" cy="648098"/>
-          </a:xfrm>
-          <a:prstGeom prst="roundRect">
-            <a:avLst/>
-          </a:prstGeom>
-          <a:solidFill>
-            <a:srgbClr val="FFC000">
-              <a:lumMod val="60000"/>
-              <a:lumOff val="40000"/>
-            </a:srgbClr>
-          </a:solidFill>
-          <a:ln w="12700" cap="flat" cmpd="sng" algn="ctr">
-            <a:solidFill>
-              <a:srgbClr val="4472C4">
-                <a:shade val="50000"/>
-              </a:srgbClr>
-            </a:solidFill>
-            <a:prstDash val="solid"/>
-            <a:miter lim="800000"/>
-          </a:ln>
-          <a:effectLst>
-            <a:outerShdw blurRad="50800" dist="38100" dir="2700000" algn="tl" rotWithShape="0">
-              <a:prstClr val="black">
-                <a:alpha val="40000"/>
-              </a:prstClr>
-            </a:outerShdw>
-          </a:effectLst>
-        </p:spPr>
-        <p:txBody>
-          <a:bodyPr rtlCol="0" anchor="ctr"/>
-          <a:lstStyle/>
-          <a:p>
-            <a:pPr marL="0" marR="0" lvl="0" indent="0" algn="ctr" defTabSz="914400" eaLnBrk="1" fontAlgn="auto" latinLnBrk="0" hangingPunct="1">
-              <a:lnSpc>
-                <a:spcPct val="100000"/>
-              </a:lnSpc>
-              <a:spcBef>
-                <a:spcPts val="0"/>
-              </a:spcBef>
-              <a:spcAft>
-                <a:spcPts val="0"/>
-              </a:spcAft>
-              <a:buClrTx/>
-              <a:buSzTx/>
-              <a:buFontTx/>
-              <a:buNone/>
-              <a:tabLst/>
-              <a:defRPr/>
-            </a:pPr>
-            <a:r>
-              <a:rPr kumimoji="0" lang="en-US" sz="1400" b="0" i="0" u="none" strike="noStrike" kern="0" cap="none" spc="0" normalizeH="0" baseline="0" noProof="0" dirty="0">
-                <a:ln>
-                  <a:noFill/>
-                </a:ln>
-                <a:solidFill>
-                  <a:srgbClr val="44546A"/>
-                </a:solidFill>
-                <a:effectLst/>
-                <a:uLnTx/>
-                <a:uFillTx/>
-                <a:latin typeface="Calibri" panose="020F0502020204030204"/>
-                <a:ea typeface="+mn-ea"/>
-                <a:cs typeface="+mn-cs"/>
-              </a:rPr>
-              <a:t>Electric Housing</a:t>
-            </a:r>
-            <a:endParaRPr kumimoji="0" lang="en-GB" sz="1400" b="0" i="0" u="none" strike="noStrike" kern="0" cap="none" spc="0" normalizeH="0" baseline="0" noProof="0" dirty="0">
-              <a:ln>
-                <a:noFill/>
-              </a:ln>
-              <a:solidFill>
-                <a:srgbClr val="44546A"/>
-              </a:solidFill>
-              <a:effectLst/>
-              <a:uLnTx/>
-              <a:uFillTx/>
-              <a:latin typeface="Calibri" panose="020F0502020204030204"/>
-              <a:ea typeface="+mn-ea"/>
-              <a:cs typeface="+mn-cs"/>
-            </a:endParaRPr>
-          </a:p>
-        </p:txBody>
-      </p:sp>
-      <p:cxnSp>
-        <p:nvCxnSpPr>
-          <p:cNvPr id="92" name="Straight Connector 29">
-            <a:extLst>
-              <a:ext uri="{FF2B5EF4-FFF2-40B4-BE49-F238E27FC236}">
-                <a16:creationId xmlns:a16="http://schemas.microsoft.com/office/drawing/2014/main" id="{471EFC45-5CF7-B921-4329-D44C0CF631AD}"/>
-              </a:ext>
-            </a:extLst>
-          </p:cNvPr>
-          <p:cNvCxnSpPr>
-            <a:cxnSpLocks/>
-          </p:cNvCxnSpPr>
-          <p:nvPr/>
-        </p:nvCxnSpPr>
-        <p:spPr>
-          <a:xfrm>
-            <a:off x="8743499" y="1417673"/>
-            <a:ext cx="0" cy="4848446"/>
-          </a:xfrm>
-          <a:prstGeom prst="line">
-            <a:avLst/>
-          </a:prstGeom>
-          <a:noFill/>
-          <a:ln w="19050" cap="flat" cmpd="sng" algn="ctr">
-            <a:solidFill>
-              <a:srgbClr val="A5A5A5"/>
-            </a:solidFill>
-            <a:prstDash val="solid"/>
-            <a:miter lim="800000"/>
-          </a:ln>
-          <a:effectLst/>
-        </p:spPr>
-      </p:cxnSp>
-      <p:sp>
-        <p:nvSpPr>
-          <p:cNvPr id="93" name="TextBox 33">
-            <a:extLst>
-              <a:ext uri="{FF2B5EF4-FFF2-40B4-BE49-F238E27FC236}">
-                <a16:creationId xmlns:a16="http://schemas.microsoft.com/office/drawing/2014/main" id="{6AC85C73-E5DB-0F4A-8F0A-1FFECE156B32}"/>
-              </a:ext>
-            </a:extLst>
-          </p:cNvPr>
-          <p:cNvSpPr txBox="1"/>
-          <p:nvPr/>
-        </p:nvSpPr>
-        <p:spPr>
-          <a:xfrm rot="16200000">
-            <a:off x="7569355" y="5041867"/>
-            <a:ext cx="2124130" cy="338554"/>
-          </a:xfrm>
-          <a:prstGeom prst="rect">
-            <a:avLst/>
-          </a:prstGeom>
-          <a:noFill/>
-        </p:spPr>
-        <p:txBody>
-          <a:bodyPr wrap="square" rtlCol="0">
-            <a:spAutoFit/>
-          </a:bodyPr>
-          <a:lstStyle/>
-          <a:p>
-            <a:pPr marL="0" marR="0" lvl="0" indent="0" defTabSz="914400" eaLnBrk="1" fontAlgn="auto" latinLnBrk="0" hangingPunct="1">
-              <a:lnSpc>
-                <a:spcPct val="100000"/>
-              </a:lnSpc>
-              <a:spcBef>
-                <a:spcPts val="0"/>
-              </a:spcBef>
-              <a:spcAft>
-                <a:spcPts val="0"/>
-              </a:spcAft>
-              <a:buClrTx/>
-              <a:buSzTx/>
-              <a:buFontTx/>
-              <a:buNone/>
-              <a:tabLst/>
-              <a:defRPr/>
-            </a:pPr>
-            <a:r>
-              <a:rPr kumimoji="0" lang="en-US" sz="1600" b="0" i="1" u="none" strike="noStrike" kern="0" cap="none" spc="0" normalizeH="0" baseline="0" noProof="0" dirty="0">
-                <a:ln>
-                  <a:noFill/>
-                </a:ln>
-                <a:solidFill>
-                  <a:prstClr val="black"/>
-                </a:solidFill>
-                <a:effectLst/>
-                <a:uLnTx/>
-                <a:uFillTx/>
-              </a:rPr>
-              <a:t>electric households</a:t>
-            </a:r>
-            <a:endParaRPr kumimoji="0" lang="en-GB" sz="1600" b="0" i="1" u="none" strike="noStrike" kern="0" cap="none" spc="0" normalizeH="0" baseline="0" noProof="0" dirty="0">
-              <a:ln>
-                <a:noFill/>
-              </a:ln>
-              <a:solidFill>
-                <a:prstClr val="black"/>
-              </a:solidFill>
-              <a:effectLst/>
-              <a:uLnTx/>
-              <a:uFillTx/>
-            </a:endParaRPr>
-          </a:p>
-        </p:txBody>
-      </p:sp>
-      <p:cxnSp>
-        <p:nvCxnSpPr>
-          <p:cNvPr id="94" name="Straight Arrow Connector 35">
-            <a:extLst>
-              <a:ext uri="{FF2B5EF4-FFF2-40B4-BE49-F238E27FC236}">
-                <a16:creationId xmlns:a16="http://schemas.microsoft.com/office/drawing/2014/main" id="{8EE4F215-7236-0C67-42D6-A5BF9620E55F}"/>
-              </a:ext>
-            </a:extLst>
-          </p:cNvPr>
-          <p:cNvCxnSpPr>
-            <a:cxnSpLocks/>
-          </p:cNvCxnSpPr>
-          <p:nvPr/>
-        </p:nvCxnSpPr>
-        <p:spPr>
-          <a:xfrm>
-            <a:off x="3445783" y="3377608"/>
-            <a:ext cx="490860" cy="0"/>
-          </a:xfrm>
-          <a:prstGeom prst="straightConnector1">
-            <a:avLst/>
-          </a:prstGeom>
-          <a:noFill/>
-          <a:ln w="19050" cap="flat" cmpd="sng" algn="ctr">
-            <a:solidFill>
-              <a:srgbClr val="A5A5A5"/>
-            </a:solidFill>
-            <a:prstDash val="solid"/>
-            <a:miter lim="800000"/>
-            <a:tailEnd type="triangle"/>
-          </a:ln>
-          <a:effectLst/>
-        </p:spPr>
-      </p:cxnSp>
-      <p:cxnSp>
-        <p:nvCxnSpPr>
-          <p:cNvPr id="95" name="Straight Arrow Connector 36">
-            <a:extLst>
-              <a:ext uri="{FF2B5EF4-FFF2-40B4-BE49-F238E27FC236}">
-                <a16:creationId xmlns:a16="http://schemas.microsoft.com/office/drawing/2014/main" id="{02B21815-6191-763F-6069-80469BC3DE46}"/>
-              </a:ext>
-            </a:extLst>
-          </p:cNvPr>
-          <p:cNvCxnSpPr>
-            <a:cxnSpLocks/>
-          </p:cNvCxnSpPr>
-          <p:nvPr/>
-        </p:nvCxnSpPr>
-        <p:spPr>
-          <a:xfrm>
-            <a:off x="3947276" y="3023269"/>
-            <a:ext cx="983560" cy="0"/>
-          </a:xfrm>
-          <a:prstGeom prst="straightConnector1">
-            <a:avLst/>
-          </a:prstGeom>
-          <a:noFill/>
-          <a:ln w="19050" cap="flat" cmpd="sng" algn="ctr">
-            <a:solidFill>
-              <a:srgbClr val="A5A5A5"/>
-            </a:solidFill>
-            <a:prstDash val="solid"/>
-            <a:miter lim="800000"/>
-            <a:tailEnd type="triangle"/>
-          </a:ln>
-          <a:effectLst/>
-        </p:spPr>
-      </p:cxnSp>
-      <p:cxnSp>
-        <p:nvCxnSpPr>
-          <p:cNvPr id="96" name="Straight Arrow Connector 37">
-            <a:extLst>
-              <a:ext uri="{FF2B5EF4-FFF2-40B4-BE49-F238E27FC236}">
-                <a16:creationId xmlns:a16="http://schemas.microsoft.com/office/drawing/2014/main" id="{17AC521C-5EF6-EF92-4655-1C8942B15CF6}"/>
-              </a:ext>
-            </a:extLst>
-          </p:cNvPr>
-          <p:cNvCxnSpPr>
-            <a:cxnSpLocks/>
-          </p:cNvCxnSpPr>
-          <p:nvPr/>
-        </p:nvCxnSpPr>
-        <p:spPr>
-          <a:xfrm>
-            <a:off x="6096000" y="3023269"/>
-            <a:ext cx="490860" cy="0"/>
-          </a:xfrm>
-          <a:prstGeom prst="straightConnector1">
-            <a:avLst/>
-          </a:prstGeom>
-          <a:noFill/>
-          <a:ln w="19050" cap="flat" cmpd="sng" algn="ctr">
-            <a:solidFill>
-              <a:srgbClr val="A5A5A5"/>
-            </a:solidFill>
-            <a:prstDash val="solid"/>
-            <a:miter lim="800000"/>
-            <a:tailEnd type="triangle"/>
-          </a:ln>
-          <a:effectLst/>
-        </p:spPr>
-      </p:cxnSp>
-      <p:cxnSp>
-        <p:nvCxnSpPr>
-          <p:cNvPr id="97" name="Straight Arrow Connector 38">
-            <a:extLst>
-              <a:ext uri="{FF2B5EF4-FFF2-40B4-BE49-F238E27FC236}">
-                <a16:creationId xmlns:a16="http://schemas.microsoft.com/office/drawing/2014/main" id="{AD8262EC-0E0D-21B1-25D9-8261FF3F9E86}"/>
-              </a:ext>
-            </a:extLst>
-          </p:cNvPr>
-          <p:cNvCxnSpPr>
-            <a:cxnSpLocks/>
-          </p:cNvCxnSpPr>
-          <p:nvPr/>
-        </p:nvCxnSpPr>
-        <p:spPr>
-          <a:xfrm>
-            <a:off x="6586860" y="3023269"/>
-            <a:ext cx="490860" cy="0"/>
-          </a:xfrm>
-          <a:prstGeom prst="straightConnector1">
-            <a:avLst/>
-          </a:prstGeom>
-          <a:noFill/>
-          <a:ln w="19050" cap="flat" cmpd="sng" algn="ctr">
-            <a:solidFill>
-              <a:srgbClr val="A5A5A5"/>
-            </a:solidFill>
-            <a:prstDash val="solid"/>
-            <a:miter lim="800000"/>
-            <a:tailEnd type="triangle"/>
-          </a:ln>
-          <a:effectLst/>
-        </p:spPr>
-      </p:cxnSp>
-      <p:cxnSp>
-        <p:nvCxnSpPr>
-          <p:cNvPr id="98" name="Straight Arrow Connector 39">
-            <a:extLst>
-              <a:ext uri="{FF2B5EF4-FFF2-40B4-BE49-F238E27FC236}">
-                <a16:creationId xmlns:a16="http://schemas.microsoft.com/office/drawing/2014/main" id="{30A5E5BC-6E66-952B-2805-B4A8768150B7}"/>
-              </a:ext>
-            </a:extLst>
-          </p:cNvPr>
-          <p:cNvCxnSpPr>
-            <a:cxnSpLocks/>
-          </p:cNvCxnSpPr>
-          <p:nvPr/>
-        </p:nvCxnSpPr>
-        <p:spPr>
-          <a:xfrm>
-            <a:off x="8247288" y="3023269"/>
-            <a:ext cx="490860" cy="0"/>
-          </a:xfrm>
-          <a:prstGeom prst="straightConnector1">
-            <a:avLst/>
-          </a:prstGeom>
-          <a:noFill/>
-          <a:ln w="19050" cap="flat" cmpd="sng" algn="ctr">
-            <a:solidFill>
-              <a:srgbClr val="A5A5A5"/>
-            </a:solidFill>
-            <a:prstDash val="solid"/>
-            <a:miter lim="800000"/>
-            <a:tailEnd type="triangle"/>
-          </a:ln>
-          <a:effectLst/>
-        </p:spPr>
-      </p:cxnSp>
-      <p:sp>
-        <p:nvSpPr>
-          <p:cNvPr id="99" name="TextBox 27">
-            <a:extLst>
-              <a:ext uri="{FF2B5EF4-FFF2-40B4-BE49-F238E27FC236}">
-                <a16:creationId xmlns:a16="http://schemas.microsoft.com/office/drawing/2014/main" id="{04BB1307-60B8-75E7-1F85-D81306EFDE57}"/>
-              </a:ext>
-            </a:extLst>
-          </p:cNvPr>
-          <p:cNvSpPr txBox="1"/>
-          <p:nvPr/>
-        </p:nvSpPr>
-        <p:spPr>
-          <a:xfrm>
-            <a:off x="3271267" y="89549"/>
-            <a:ext cx="2052083" cy="646331"/>
-          </a:xfrm>
-          <a:prstGeom prst="rect">
-            <a:avLst/>
-          </a:prstGeom>
-          <a:noFill/>
-        </p:spPr>
-        <p:txBody>
-          <a:bodyPr wrap="square" rtlCol="0">
-            <a:spAutoFit/>
-          </a:bodyPr>
-          <a:lstStyle/>
-          <a:p>
-            <a:pPr marL="0" marR="0" lvl="0" indent="0" algn="ctr" defTabSz="914400" eaLnBrk="1" fontAlgn="auto" latinLnBrk="0" hangingPunct="1">
-              <a:lnSpc>
-                <a:spcPct val="100000"/>
-              </a:lnSpc>
-              <a:spcBef>
-                <a:spcPts val="0"/>
-              </a:spcBef>
-              <a:spcAft>
-                <a:spcPts val="0"/>
-              </a:spcAft>
-              <a:buClrTx/>
-              <a:buSzTx/>
-              <a:buFontTx/>
-              <a:buNone/>
-              <a:tabLst/>
-              <a:defRPr/>
-            </a:pPr>
-            <a:r>
-              <a:rPr kumimoji="0" lang="en-US" sz="1800" b="0" i="0" u="none" strike="noStrike" kern="0" cap="none" spc="0" normalizeH="0" baseline="0" noProof="0" dirty="0">
-                <a:ln>
-                  <a:noFill/>
-                </a:ln>
-                <a:solidFill>
-                  <a:prstClr val="black"/>
-                </a:solidFill>
-                <a:effectLst/>
-                <a:uLnTx/>
-                <a:uFillTx/>
-              </a:rPr>
-              <a:t>Secondary</a:t>
-            </a:r>
-          </a:p>
-          <a:p>
-            <a:pPr marL="0" marR="0" lvl="0" indent="0" algn="ctr" defTabSz="914400" eaLnBrk="1" fontAlgn="auto" latinLnBrk="0" hangingPunct="1">
-              <a:lnSpc>
-                <a:spcPct val="100000"/>
-              </a:lnSpc>
-              <a:spcBef>
-                <a:spcPts val="0"/>
-              </a:spcBef>
-              <a:spcAft>
-                <a:spcPts val="0"/>
-              </a:spcAft>
-              <a:buClrTx/>
-              <a:buSzTx/>
-              <a:buFontTx/>
-              <a:buNone/>
-              <a:tabLst/>
-              <a:defRPr/>
-            </a:pPr>
-            <a:r>
-              <a:rPr kumimoji="0" lang="en-US" sz="1800" b="0" i="0" u="none" strike="noStrike" kern="0" cap="none" spc="0" normalizeH="0" baseline="0" noProof="0" dirty="0">
-                <a:ln>
-                  <a:noFill/>
-                </a:ln>
-                <a:solidFill>
-                  <a:prstClr val="black"/>
-                </a:solidFill>
-                <a:effectLst/>
-                <a:uLnTx/>
-                <a:uFillTx/>
-              </a:rPr>
-              <a:t> Energy</a:t>
-            </a:r>
-            <a:endParaRPr kumimoji="0" lang="en-GB" sz="1800" b="0" i="0" u="none" strike="noStrike" kern="0" cap="none" spc="0" normalizeH="0" baseline="0" noProof="0" dirty="0">
-              <a:ln>
-                <a:noFill/>
-              </a:ln>
-              <a:solidFill>
-                <a:prstClr val="black"/>
-              </a:solidFill>
-              <a:effectLst/>
-              <a:uLnTx/>
-              <a:uFillTx/>
-            </a:endParaRPr>
-          </a:p>
-        </p:txBody>
-      </p:sp>
-      <p:sp>
-        <p:nvSpPr>
-          <p:cNvPr id="100" name="TextBox 28">
-            <a:extLst>
-              <a:ext uri="{FF2B5EF4-FFF2-40B4-BE49-F238E27FC236}">
-                <a16:creationId xmlns:a16="http://schemas.microsoft.com/office/drawing/2014/main" id="{08FAA502-A4BB-9EDF-6308-A67521C9A04B}"/>
-              </a:ext>
-            </a:extLst>
-          </p:cNvPr>
-          <p:cNvSpPr txBox="1"/>
-          <p:nvPr/>
-        </p:nvSpPr>
-        <p:spPr>
-          <a:xfrm>
-            <a:off x="5776274" y="89549"/>
-            <a:ext cx="2052083" cy="646331"/>
-          </a:xfrm>
-          <a:prstGeom prst="rect">
-            <a:avLst/>
-          </a:prstGeom>
-          <a:noFill/>
-        </p:spPr>
-        <p:txBody>
-          <a:bodyPr wrap="square" rtlCol="0">
-            <a:spAutoFit/>
-          </a:bodyPr>
-          <a:lstStyle/>
-          <a:p>
-            <a:pPr marL="0" marR="0" lvl="0" indent="0" algn="ctr" defTabSz="914400" eaLnBrk="1" fontAlgn="auto" latinLnBrk="0" hangingPunct="1">
-              <a:lnSpc>
-                <a:spcPct val="100000"/>
-              </a:lnSpc>
-              <a:spcBef>
-                <a:spcPts val="0"/>
-              </a:spcBef>
-              <a:spcAft>
-                <a:spcPts val="0"/>
-              </a:spcAft>
-              <a:buClrTx/>
-              <a:buSzTx/>
-              <a:buFontTx/>
-              <a:buNone/>
-              <a:tabLst/>
-              <a:defRPr/>
-            </a:pPr>
-            <a:r>
-              <a:rPr kumimoji="0" lang="en-US" sz="1800" b="0" i="0" u="none" strike="noStrike" kern="0" cap="none" spc="0" normalizeH="0" baseline="0" noProof="0" dirty="0">
-                <a:ln>
-                  <a:noFill/>
-                </a:ln>
-                <a:solidFill>
-                  <a:prstClr val="black"/>
-                </a:solidFill>
-                <a:effectLst/>
-                <a:uLnTx/>
-                <a:uFillTx/>
-              </a:rPr>
-              <a:t>Final</a:t>
-            </a:r>
-          </a:p>
-          <a:p>
-            <a:pPr marL="0" marR="0" lvl="0" indent="0" algn="ctr" defTabSz="914400" eaLnBrk="1" fontAlgn="auto" latinLnBrk="0" hangingPunct="1">
-              <a:lnSpc>
-                <a:spcPct val="100000"/>
-              </a:lnSpc>
-              <a:spcBef>
-                <a:spcPts val="0"/>
-              </a:spcBef>
-              <a:spcAft>
-                <a:spcPts val="0"/>
-              </a:spcAft>
-              <a:buClrTx/>
-              <a:buSzTx/>
-              <a:buFontTx/>
-              <a:buNone/>
-              <a:tabLst/>
-              <a:defRPr/>
-            </a:pPr>
-            <a:r>
-              <a:rPr kumimoji="0" lang="en-US" sz="1800" b="0" i="0" u="none" strike="noStrike" kern="0" cap="none" spc="0" normalizeH="0" baseline="0" noProof="0" dirty="0">
-                <a:ln>
-                  <a:noFill/>
-                </a:ln>
-                <a:solidFill>
-                  <a:prstClr val="black"/>
-                </a:solidFill>
-                <a:effectLst/>
-                <a:uLnTx/>
-                <a:uFillTx/>
-              </a:rPr>
-              <a:t> Energy</a:t>
-            </a:r>
-            <a:endParaRPr kumimoji="0" lang="en-GB" sz="1800" b="0" i="0" u="none" strike="noStrike" kern="0" cap="none" spc="0" normalizeH="0" baseline="0" noProof="0" dirty="0">
-              <a:ln>
-                <a:noFill/>
-              </a:ln>
-              <a:solidFill>
-                <a:prstClr val="black"/>
-              </a:solidFill>
-              <a:effectLst/>
-              <a:uLnTx/>
-              <a:uFillTx/>
-            </a:endParaRPr>
-          </a:p>
-        </p:txBody>
-      </p:sp>
-      <p:sp>
-        <p:nvSpPr>
-          <p:cNvPr id="101" name="TextBox 30">
-            <a:extLst>
-              <a:ext uri="{FF2B5EF4-FFF2-40B4-BE49-F238E27FC236}">
-                <a16:creationId xmlns:a16="http://schemas.microsoft.com/office/drawing/2014/main" id="{2E41079E-BBEF-C16C-BE3B-82E7DD6A84EB}"/>
-              </a:ext>
-            </a:extLst>
-          </p:cNvPr>
-          <p:cNvSpPr txBox="1"/>
-          <p:nvPr/>
-        </p:nvSpPr>
-        <p:spPr>
-          <a:xfrm>
-            <a:off x="7841528" y="103706"/>
-            <a:ext cx="2052083" cy="646331"/>
-          </a:xfrm>
-          <a:prstGeom prst="rect">
-            <a:avLst/>
-          </a:prstGeom>
-          <a:noFill/>
-        </p:spPr>
-        <p:txBody>
-          <a:bodyPr wrap="square" rtlCol="0">
-            <a:spAutoFit/>
-          </a:bodyPr>
-          <a:lstStyle/>
-          <a:p>
-            <a:pPr marL="0" marR="0" lvl="0" indent="0" algn="ctr" defTabSz="914400" eaLnBrk="1" fontAlgn="auto" latinLnBrk="0" hangingPunct="1">
-              <a:lnSpc>
-                <a:spcPct val="100000"/>
-              </a:lnSpc>
-              <a:spcBef>
-                <a:spcPts val="0"/>
-              </a:spcBef>
-              <a:spcAft>
-                <a:spcPts val="0"/>
-              </a:spcAft>
-              <a:buClrTx/>
-              <a:buSzTx/>
-              <a:buFontTx/>
-              <a:buNone/>
-              <a:tabLst/>
-              <a:defRPr/>
-            </a:pPr>
-            <a:r>
-              <a:rPr kumimoji="0" lang="en-US" sz="1800" b="0" i="0" u="none" strike="noStrike" kern="0" cap="none" spc="0" normalizeH="0" baseline="0" noProof="0" dirty="0">
-                <a:ln>
-                  <a:noFill/>
-                </a:ln>
-                <a:solidFill>
-                  <a:prstClr val="black"/>
-                </a:solidFill>
-                <a:effectLst/>
-                <a:uLnTx/>
-                <a:uFillTx/>
-              </a:rPr>
-              <a:t>Final</a:t>
-            </a:r>
-          </a:p>
-          <a:p>
-            <a:pPr marL="0" marR="0" lvl="0" indent="0" algn="ctr" defTabSz="914400" eaLnBrk="1" fontAlgn="auto" latinLnBrk="0" hangingPunct="1">
-              <a:lnSpc>
-                <a:spcPct val="100000"/>
-              </a:lnSpc>
-              <a:spcBef>
-                <a:spcPts val="0"/>
-              </a:spcBef>
-              <a:spcAft>
-                <a:spcPts val="0"/>
-              </a:spcAft>
-              <a:buClrTx/>
-              <a:buSzTx/>
-              <a:buFontTx/>
-              <a:buNone/>
-              <a:tabLst/>
-              <a:defRPr/>
-            </a:pPr>
-            <a:r>
-              <a:rPr kumimoji="0" lang="en-US" sz="1800" b="0" i="0" u="none" strike="noStrike" kern="0" cap="none" spc="0" normalizeH="0" baseline="0" noProof="0" dirty="0">
-                <a:ln>
-                  <a:noFill/>
-                </a:ln>
-                <a:solidFill>
-                  <a:prstClr val="black"/>
-                </a:solidFill>
-                <a:effectLst/>
-                <a:uLnTx/>
-                <a:uFillTx/>
-              </a:rPr>
-              <a:t> Energy</a:t>
-            </a:r>
-            <a:endParaRPr kumimoji="0" lang="en-GB" sz="1800" b="0" i="0" u="none" strike="noStrike" kern="0" cap="none" spc="0" normalizeH="0" baseline="0" noProof="0" dirty="0">
-              <a:ln>
-                <a:noFill/>
-              </a:ln>
-              <a:solidFill>
-                <a:prstClr val="black"/>
-              </a:solidFill>
-              <a:effectLst/>
-              <a:uLnTx/>
-              <a:uFillTx/>
-            </a:endParaRPr>
-          </a:p>
-        </p:txBody>
-      </p:sp>
-      <p:sp>
-        <p:nvSpPr>
-          <p:cNvPr id="103" name="Rectangle: Rounded Corners 26">
-            <a:extLst>
-              <a:ext uri="{FF2B5EF4-FFF2-40B4-BE49-F238E27FC236}">
-                <a16:creationId xmlns:a16="http://schemas.microsoft.com/office/drawing/2014/main" id="{E193C1A7-BA46-B5E6-79A9-D3698A7686B0}"/>
-              </a:ext>
-            </a:extLst>
-          </p:cNvPr>
-          <p:cNvSpPr/>
-          <p:nvPr/>
-        </p:nvSpPr>
-        <p:spPr>
-          <a:xfrm>
-            <a:off x="9248504" y="2699220"/>
-            <a:ext cx="1167812" cy="648098"/>
-          </a:xfrm>
-          <a:prstGeom prst="roundRect">
-            <a:avLst/>
-          </a:prstGeom>
-          <a:solidFill>
-            <a:srgbClr val="FFC000">
-              <a:lumMod val="60000"/>
-              <a:lumOff val="40000"/>
-            </a:srgbClr>
-          </a:solidFill>
-          <a:ln w="12700" cap="flat" cmpd="sng" algn="ctr">
-            <a:solidFill>
-              <a:srgbClr val="4472C4">
-                <a:shade val="50000"/>
-              </a:srgbClr>
-            </a:solidFill>
-            <a:prstDash val="solid"/>
-            <a:miter lim="800000"/>
-          </a:ln>
-          <a:effectLst>
-            <a:outerShdw blurRad="50800" dist="38100" dir="2700000" algn="tl" rotWithShape="0">
-              <a:prstClr val="black">
-                <a:alpha val="40000"/>
-              </a:prstClr>
-            </a:outerShdw>
-          </a:effectLst>
-        </p:spPr>
-        <p:txBody>
-          <a:bodyPr rtlCol="0" anchor="ctr"/>
-          <a:lstStyle/>
-          <a:p>
-            <a:pPr marL="0" marR="0" lvl="0" indent="0" algn="ctr" defTabSz="914400" eaLnBrk="1" fontAlgn="auto" latinLnBrk="0" hangingPunct="1">
-              <a:lnSpc>
-                <a:spcPct val="100000"/>
-              </a:lnSpc>
-              <a:spcBef>
-                <a:spcPts val="0"/>
-              </a:spcBef>
-              <a:spcAft>
-                <a:spcPts val="0"/>
-              </a:spcAft>
-              <a:buClrTx/>
-              <a:buSzTx/>
-              <a:buFontTx/>
-              <a:buNone/>
-              <a:tabLst/>
-              <a:defRPr/>
-            </a:pPr>
-            <a:r>
-              <a:rPr kumimoji="0" lang="en-US" sz="1400" b="0" i="0" u="none" strike="noStrike" kern="0" cap="none" spc="0" normalizeH="0" baseline="0" noProof="0" dirty="0">
-                <a:ln>
-                  <a:noFill/>
-                </a:ln>
-                <a:solidFill>
-                  <a:srgbClr val="44546A"/>
-                </a:solidFill>
-                <a:effectLst/>
-                <a:uLnTx/>
-                <a:uFillTx/>
-                <a:latin typeface="Calibri" panose="020F0502020204030204"/>
-                <a:ea typeface="+mn-ea"/>
-                <a:cs typeface="+mn-cs"/>
-              </a:rPr>
-              <a:t>Bulb</a:t>
-            </a:r>
-            <a:endParaRPr kumimoji="0" lang="en-GB" sz="1400" b="0" i="0" u="none" strike="noStrike" kern="0" cap="none" spc="0" normalizeH="0" baseline="0" noProof="0" dirty="0">
-              <a:ln>
-                <a:noFill/>
-              </a:ln>
-              <a:solidFill>
-                <a:srgbClr val="44546A"/>
-              </a:solidFill>
-              <a:effectLst/>
-              <a:uLnTx/>
-              <a:uFillTx/>
-              <a:latin typeface="Calibri" panose="020F0502020204030204"/>
-              <a:ea typeface="+mn-ea"/>
-              <a:cs typeface="+mn-cs"/>
-            </a:endParaRPr>
-          </a:p>
-        </p:txBody>
-      </p:sp>
-      <p:cxnSp>
-        <p:nvCxnSpPr>
-          <p:cNvPr id="104" name="Straight Connector 29">
-            <a:extLst>
-              <a:ext uri="{FF2B5EF4-FFF2-40B4-BE49-F238E27FC236}">
-                <a16:creationId xmlns:a16="http://schemas.microsoft.com/office/drawing/2014/main" id="{F78D585F-73C3-456E-5AF8-FEF0E82A3698}"/>
-              </a:ext>
-            </a:extLst>
-          </p:cNvPr>
-          <p:cNvCxnSpPr>
-            <a:cxnSpLocks/>
-          </p:cNvCxnSpPr>
-          <p:nvPr/>
-        </p:nvCxnSpPr>
-        <p:spPr>
-          <a:xfrm>
-            <a:off x="10912527" y="1417673"/>
-            <a:ext cx="0" cy="4848446"/>
-          </a:xfrm>
-          <a:prstGeom prst="line">
-            <a:avLst/>
-          </a:prstGeom>
-          <a:noFill/>
-          <a:ln w="19050" cap="flat" cmpd="sng" algn="ctr">
-            <a:solidFill>
-              <a:srgbClr val="A5A5A5"/>
-            </a:solidFill>
-            <a:prstDash val="solid"/>
-            <a:miter lim="800000"/>
-          </a:ln>
-          <a:effectLst/>
-        </p:spPr>
-      </p:cxnSp>
-      <p:sp>
-        <p:nvSpPr>
-          <p:cNvPr id="105" name="TextBox 33">
-            <a:extLst>
-              <a:ext uri="{FF2B5EF4-FFF2-40B4-BE49-F238E27FC236}">
-                <a16:creationId xmlns:a16="http://schemas.microsoft.com/office/drawing/2014/main" id="{4A53749E-7FA3-D8A9-BD56-7CFFAAC96B54}"/>
-              </a:ext>
-            </a:extLst>
-          </p:cNvPr>
-          <p:cNvSpPr txBox="1"/>
-          <p:nvPr/>
-        </p:nvSpPr>
-        <p:spPr>
-          <a:xfrm rot="16200000">
-            <a:off x="9738382" y="5041866"/>
-            <a:ext cx="2124132" cy="338554"/>
-          </a:xfrm>
-          <a:prstGeom prst="rect">
-            <a:avLst/>
-          </a:prstGeom>
-          <a:noFill/>
-        </p:spPr>
-        <p:txBody>
-          <a:bodyPr wrap="square" rtlCol="0">
-            <a:spAutoFit/>
-          </a:bodyPr>
-          <a:lstStyle/>
-          <a:p>
-            <a:pPr marL="0" marR="0" lvl="0" indent="0" defTabSz="914400" eaLnBrk="1" fontAlgn="auto" latinLnBrk="0" hangingPunct="1">
-              <a:lnSpc>
-                <a:spcPct val="100000"/>
-              </a:lnSpc>
-              <a:spcBef>
-                <a:spcPts val="0"/>
-              </a:spcBef>
-              <a:spcAft>
-                <a:spcPts val="0"/>
-              </a:spcAft>
-              <a:buClrTx/>
-              <a:buSzTx/>
-              <a:buFontTx/>
-              <a:buNone/>
-              <a:tabLst/>
-              <a:defRPr/>
-            </a:pPr>
-            <a:r>
-              <a:rPr kumimoji="0" lang="en-US" sz="1600" b="0" i="1" u="none" strike="noStrike" kern="0" cap="none" spc="0" normalizeH="0" baseline="0" noProof="0" dirty="0">
-                <a:ln>
-                  <a:noFill/>
-                </a:ln>
-                <a:solidFill>
-                  <a:prstClr val="black"/>
-                </a:solidFill>
-                <a:effectLst/>
-                <a:uLnTx/>
-                <a:uFillTx/>
-              </a:rPr>
-              <a:t>electric households</a:t>
-            </a:r>
-            <a:endParaRPr kumimoji="0" lang="en-GB" sz="1600" b="0" i="1" u="none" strike="noStrike" kern="0" cap="none" spc="0" normalizeH="0" baseline="0" noProof="0" dirty="0">
-              <a:ln>
-                <a:noFill/>
-              </a:ln>
-              <a:solidFill>
-                <a:prstClr val="black"/>
-              </a:solidFill>
-              <a:effectLst/>
-              <a:uLnTx/>
-              <a:uFillTx/>
-            </a:endParaRPr>
-          </a:p>
-        </p:txBody>
-      </p:sp>
-      <p:cxnSp>
-        <p:nvCxnSpPr>
-          <p:cNvPr id="106" name="Straight Arrow Connector 38">
-            <a:extLst>
-              <a:ext uri="{FF2B5EF4-FFF2-40B4-BE49-F238E27FC236}">
-                <a16:creationId xmlns:a16="http://schemas.microsoft.com/office/drawing/2014/main" id="{816B9D10-1FC6-6B6A-475B-032E9AB127A0}"/>
-              </a:ext>
-            </a:extLst>
-          </p:cNvPr>
-          <p:cNvCxnSpPr>
-            <a:cxnSpLocks/>
-          </p:cNvCxnSpPr>
-          <p:nvPr/>
-        </p:nvCxnSpPr>
-        <p:spPr>
-          <a:xfrm>
-            <a:off x="8755888" y="3023269"/>
-            <a:ext cx="490860" cy="0"/>
-          </a:xfrm>
-          <a:prstGeom prst="straightConnector1">
-            <a:avLst/>
-          </a:prstGeom>
-          <a:noFill/>
-          <a:ln w="19050" cap="flat" cmpd="sng" algn="ctr">
-            <a:solidFill>
-              <a:srgbClr val="A5A5A5"/>
-            </a:solidFill>
-            <a:prstDash val="solid"/>
-            <a:miter lim="800000"/>
-            <a:tailEnd type="triangle"/>
-          </a:ln>
-          <a:effectLst/>
-        </p:spPr>
-      </p:cxnSp>
-      <p:cxnSp>
-        <p:nvCxnSpPr>
-          <p:cNvPr id="107" name="Straight Arrow Connector 39">
-            <a:extLst>
-              <a:ext uri="{FF2B5EF4-FFF2-40B4-BE49-F238E27FC236}">
-                <a16:creationId xmlns:a16="http://schemas.microsoft.com/office/drawing/2014/main" id="{82B4DD46-728A-8E42-9A39-5D7B2F9BB473}"/>
-              </a:ext>
-            </a:extLst>
-          </p:cNvPr>
-          <p:cNvCxnSpPr>
-            <a:cxnSpLocks/>
-          </p:cNvCxnSpPr>
-          <p:nvPr/>
-        </p:nvCxnSpPr>
-        <p:spPr>
-          <a:xfrm>
-            <a:off x="10416316" y="3023269"/>
-            <a:ext cx="490860" cy="0"/>
-          </a:xfrm>
-          <a:prstGeom prst="straightConnector1">
-            <a:avLst/>
-          </a:prstGeom>
-          <a:noFill/>
-          <a:ln w="19050" cap="flat" cmpd="sng" algn="ctr">
-            <a:solidFill>
-              <a:srgbClr val="A5A5A5"/>
-            </a:solidFill>
-            <a:prstDash val="solid"/>
-            <a:miter lim="800000"/>
-            <a:tailEnd type="triangle"/>
-          </a:ln>
-          <a:effectLst/>
-        </p:spPr>
-      </p:cxnSp>
-      <p:sp>
-        <p:nvSpPr>
-          <p:cNvPr id="108" name="TextBox 30">
-            <a:extLst>
-              <a:ext uri="{FF2B5EF4-FFF2-40B4-BE49-F238E27FC236}">
-                <a16:creationId xmlns:a16="http://schemas.microsoft.com/office/drawing/2014/main" id="{28470607-56E8-A813-AA13-D9078BA88FAC}"/>
-              </a:ext>
-            </a:extLst>
-          </p:cNvPr>
-          <p:cNvSpPr txBox="1"/>
-          <p:nvPr/>
-        </p:nvSpPr>
-        <p:spPr>
-          <a:xfrm>
-            <a:off x="10010556" y="103706"/>
-            <a:ext cx="2052083" cy="646331"/>
-          </a:xfrm>
-          <a:prstGeom prst="rect">
-            <a:avLst/>
-          </a:prstGeom>
-          <a:noFill/>
-        </p:spPr>
-        <p:txBody>
-          <a:bodyPr wrap="square" rtlCol="0">
-            <a:spAutoFit/>
-          </a:bodyPr>
-          <a:lstStyle/>
-          <a:p>
-            <a:pPr marL="0" marR="0" lvl="0" indent="0" algn="ctr" defTabSz="914400" eaLnBrk="1" fontAlgn="auto" latinLnBrk="0" hangingPunct="1">
-              <a:lnSpc>
-                <a:spcPct val="100000"/>
-              </a:lnSpc>
-              <a:spcBef>
-                <a:spcPts val="0"/>
-              </a:spcBef>
-              <a:spcAft>
-                <a:spcPts val="0"/>
-              </a:spcAft>
-              <a:buClrTx/>
-              <a:buSzTx/>
-              <a:buFontTx/>
-              <a:buNone/>
-              <a:tabLst/>
-              <a:defRPr/>
-            </a:pPr>
-            <a:r>
-              <a:rPr kumimoji="0" lang="en-US" sz="1800" b="0" i="0" u="none" strike="noStrike" kern="0" cap="none" spc="0" normalizeH="0" baseline="0" noProof="0" dirty="0">
-                <a:ln>
-                  <a:noFill/>
-                </a:ln>
-                <a:solidFill>
-                  <a:prstClr val="black"/>
-                </a:solidFill>
-                <a:effectLst/>
-                <a:uLnTx/>
-                <a:uFillTx/>
-              </a:rPr>
-              <a:t>Useful</a:t>
-            </a:r>
-          </a:p>
-          <a:p>
-            <a:pPr marL="0" marR="0" lvl="0" indent="0" algn="ctr" defTabSz="914400" eaLnBrk="1" fontAlgn="auto" latinLnBrk="0" hangingPunct="1">
-              <a:lnSpc>
-                <a:spcPct val="100000"/>
-              </a:lnSpc>
-              <a:spcBef>
-                <a:spcPts val="0"/>
-              </a:spcBef>
-              <a:spcAft>
-                <a:spcPts val="0"/>
-              </a:spcAft>
-              <a:buClrTx/>
-              <a:buSzTx/>
-              <a:buFontTx/>
-              <a:buNone/>
-              <a:tabLst/>
-              <a:defRPr/>
-            </a:pPr>
-            <a:r>
-              <a:rPr kumimoji="0" lang="en-US" sz="1800" b="0" i="0" u="none" strike="noStrike" kern="0" cap="none" spc="0" normalizeH="0" baseline="0" noProof="0" dirty="0">
-                <a:ln>
-                  <a:noFill/>
-                </a:ln>
-                <a:solidFill>
-                  <a:prstClr val="black"/>
-                </a:solidFill>
-                <a:effectLst/>
-                <a:uLnTx/>
-                <a:uFillTx/>
-              </a:rPr>
-              <a:t> Energy</a:t>
-            </a:r>
-            <a:endParaRPr kumimoji="0" lang="en-GB" sz="1800" b="0" i="0" u="none" strike="noStrike" kern="0" cap="none" spc="0" normalizeH="0" baseline="0" noProof="0" dirty="0">
-              <a:ln>
-                <a:noFill/>
-              </a:ln>
-              <a:solidFill>
-                <a:prstClr val="black"/>
-              </a:solidFill>
-              <a:effectLst/>
-              <a:uLnTx/>
-              <a:uFillTx/>
-            </a:endParaRPr>
-          </a:p>
-        </p:txBody>
-      </p:sp>
-      <p:sp>
-        <p:nvSpPr>
-          <p:cNvPr id="2" name="CaixaDeTexto 1">
-            <a:extLst>
-              <a:ext uri="{FF2B5EF4-FFF2-40B4-BE49-F238E27FC236}">
-                <a16:creationId xmlns:a16="http://schemas.microsoft.com/office/drawing/2014/main" id="{62119D21-DABB-0B06-D5F1-118B0B876BAF}"/>
-              </a:ext>
-            </a:extLst>
-          </p:cNvPr>
-          <p:cNvSpPr txBox="1"/>
-          <p:nvPr/>
-        </p:nvSpPr>
-        <p:spPr>
-          <a:xfrm rot="5400000">
-            <a:off x="2733463" y="3726944"/>
-            <a:ext cx="458780" cy="523220"/>
-          </a:xfrm>
-          <a:prstGeom prst="rect">
-            <a:avLst/>
-          </a:prstGeom>
-          <a:noFill/>
-        </p:spPr>
-        <p:txBody>
-          <a:bodyPr wrap="none" rtlCol="0">
-            <a:spAutoFit/>
-          </a:bodyPr>
-          <a:lstStyle/>
-          <a:p>
-            <a:r>
-              <a:rPr lang="pt-BR" sz="2800" dirty="0"/>
-              <a:t>...</a:t>
-            </a:r>
-          </a:p>
-        </p:txBody>
-      </p:sp>
-      <p:sp>
-        <p:nvSpPr>
-          <p:cNvPr id="3" name="Rectangle: Rounded Corners 5">
-            <a:extLst>
-              <a:ext uri="{FF2B5EF4-FFF2-40B4-BE49-F238E27FC236}">
-                <a16:creationId xmlns:a16="http://schemas.microsoft.com/office/drawing/2014/main" id="{9326FB87-747C-A474-1B83-1E5B5A2EEA9E}"/>
-              </a:ext>
-            </a:extLst>
-          </p:cNvPr>
-          <p:cNvSpPr/>
-          <p:nvPr/>
-        </p:nvSpPr>
-        <p:spPr>
-          <a:xfrm>
-            <a:off x="2264022" y="4307395"/>
-            <a:ext cx="1167812" cy="648098"/>
-          </a:xfrm>
-          <a:prstGeom prst="roundRect">
-            <a:avLst/>
-          </a:prstGeom>
-          <a:solidFill>
-            <a:srgbClr val="4472C4"/>
-          </a:solidFill>
-          <a:ln w="12700" cap="flat" cmpd="sng" algn="ctr">
-            <a:solidFill>
-              <a:srgbClr val="4472C4">
-                <a:shade val="50000"/>
-              </a:srgbClr>
-            </a:solidFill>
-            <a:prstDash val="solid"/>
-            <a:miter lim="800000"/>
-          </a:ln>
-          <a:effectLst>
-            <a:outerShdw blurRad="50800" dist="38100" dir="2700000" algn="tl" rotWithShape="0">
-              <a:prstClr val="black">
-                <a:alpha val="40000"/>
-              </a:prstClr>
-            </a:outerShdw>
-          </a:effectLst>
-        </p:spPr>
-        <p:txBody>
-          <a:bodyPr rtlCol="0" anchor="ctr"/>
-          <a:lstStyle/>
-          <a:p>
-            <a:pPr marL="0" marR="0" lvl="0" indent="0" algn="ctr" defTabSz="914400" eaLnBrk="1" fontAlgn="auto" latinLnBrk="0" hangingPunct="1">
-              <a:lnSpc>
-                <a:spcPct val="100000"/>
-              </a:lnSpc>
-              <a:spcBef>
-                <a:spcPts val="0"/>
-              </a:spcBef>
-              <a:spcAft>
-                <a:spcPts val="0"/>
-              </a:spcAft>
-              <a:buClrTx/>
-              <a:buSzTx/>
-              <a:buFontTx/>
-              <a:buNone/>
-              <a:tabLst/>
-              <a:defRPr/>
-            </a:pPr>
-            <a:r>
-              <a:rPr kumimoji="0" lang="en-US" sz="1400" b="0" i="0" u="none" strike="noStrike" kern="0" cap="none" spc="0" normalizeH="0" baseline="0" noProof="0" dirty="0">
-                <a:ln>
-                  <a:noFill/>
-                </a:ln>
-                <a:solidFill>
-                  <a:prstClr val="white"/>
-                </a:solidFill>
-                <a:effectLst/>
-                <a:uLnTx/>
-                <a:uFillTx/>
-                <a:latin typeface="Calibri" panose="020F0502020204030204"/>
-                <a:ea typeface="+mn-ea"/>
-                <a:cs typeface="+mn-cs"/>
-              </a:rPr>
-              <a:t>Oil Power plant</a:t>
-            </a:r>
-            <a:endParaRPr kumimoji="0" lang="en-GB" sz="1400" b="0" i="0" u="none" strike="noStrike" kern="0" cap="none" spc="0" normalizeH="0" baseline="0" noProof="0" dirty="0">
-              <a:ln>
-                <a:noFill/>
-              </a:ln>
-              <a:solidFill>
-                <a:prstClr val="white"/>
-              </a:solidFill>
-              <a:effectLst/>
-              <a:uLnTx/>
-              <a:uFillTx/>
-              <a:latin typeface="Calibri" panose="020F0502020204030204"/>
-              <a:ea typeface="+mn-ea"/>
-              <a:cs typeface="+mn-cs"/>
-            </a:endParaRPr>
-          </a:p>
-        </p:txBody>
-      </p:sp>
-      <p:cxnSp>
-        <p:nvCxnSpPr>
-          <p:cNvPr id="4" name="Straight Arrow Connector 18">
-            <a:extLst>
-              <a:ext uri="{FF2B5EF4-FFF2-40B4-BE49-F238E27FC236}">
-                <a16:creationId xmlns:a16="http://schemas.microsoft.com/office/drawing/2014/main" id="{8C27BC5D-AE18-F665-B33C-F1DC4AD34125}"/>
-              </a:ext>
-            </a:extLst>
-          </p:cNvPr>
-          <p:cNvCxnSpPr>
-            <a:cxnSpLocks/>
-          </p:cNvCxnSpPr>
-          <p:nvPr/>
-        </p:nvCxnSpPr>
-        <p:spPr>
-          <a:xfrm>
-            <a:off x="3442467" y="4612273"/>
-            <a:ext cx="490860" cy="0"/>
-          </a:xfrm>
-          <a:prstGeom prst="straightConnector1">
-            <a:avLst/>
-          </a:prstGeom>
-          <a:noFill/>
-          <a:ln w="19050" cap="flat" cmpd="sng" algn="ctr">
-            <a:solidFill>
-              <a:srgbClr val="A5A5A5"/>
-            </a:solidFill>
-            <a:prstDash val="solid"/>
-            <a:miter lim="800000"/>
-            <a:tailEnd type="triangle"/>
-          </a:ln>
-          <a:effectLst/>
-        </p:spPr>
-      </p:cxnSp>
-      <p:cxnSp>
-        <p:nvCxnSpPr>
-          <p:cNvPr id="6" name="Straight Connector 9">
-            <a:extLst>
-              <a:ext uri="{FF2B5EF4-FFF2-40B4-BE49-F238E27FC236}">
-                <a16:creationId xmlns:a16="http://schemas.microsoft.com/office/drawing/2014/main" id="{B2E4AB54-4E3E-01B9-D95D-AD7CEB7D5E25}"/>
-              </a:ext>
-            </a:extLst>
-          </p:cNvPr>
-          <p:cNvCxnSpPr>
-            <a:cxnSpLocks/>
-          </p:cNvCxnSpPr>
-          <p:nvPr/>
-        </p:nvCxnSpPr>
-        <p:spPr>
-          <a:xfrm>
-            <a:off x="4087272" y="1748906"/>
-            <a:ext cx="0" cy="4848446"/>
-          </a:xfrm>
-          <a:prstGeom prst="line">
-            <a:avLst/>
-          </a:prstGeom>
-          <a:noFill/>
-          <a:ln w="19050" cap="flat" cmpd="sng" algn="ctr">
-            <a:solidFill>
-              <a:srgbClr val="A5A5A5"/>
-            </a:solidFill>
-            <a:prstDash val="solid"/>
-            <a:miter lim="800000"/>
-          </a:ln>
-          <a:effectLst/>
-        </p:spPr>
-      </p:cxnSp>
-      <p:sp>
-        <p:nvSpPr>
-          <p:cNvPr id="7" name="Rectangle: Rounded Corners 20">
-            <a:extLst>
-              <a:ext uri="{FF2B5EF4-FFF2-40B4-BE49-F238E27FC236}">
-                <a16:creationId xmlns:a16="http://schemas.microsoft.com/office/drawing/2014/main" id="{BEC10CBA-B985-9F18-4FC8-6A481E0BC43E}"/>
-              </a:ext>
-            </a:extLst>
-          </p:cNvPr>
-          <p:cNvSpPr/>
-          <p:nvPr/>
-        </p:nvSpPr>
-        <p:spPr>
-          <a:xfrm>
-            <a:off x="5081659" y="3790179"/>
-            <a:ext cx="1167812" cy="648098"/>
-          </a:xfrm>
-          <a:prstGeom prst="roundRect">
-            <a:avLst/>
-          </a:prstGeom>
-          <a:solidFill>
-            <a:srgbClr val="A5A5A5"/>
-          </a:solidFill>
-          <a:ln w="12700" cap="flat" cmpd="sng" algn="ctr">
-            <a:solidFill>
-              <a:srgbClr val="4472C4">
-                <a:shade val="50000"/>
-              </a:srgbClr>
-            </a:solidFill>
-            <a:prstDash val="solid"/>
-            <a:miter lim="800000"/>
-          </a:ln>
-          <a:effectLst>
-            <a:outerShdw blurRad="50800" dist="38100" dir="2700000" algn="tl" rotWithShape="0">
-              <a:prstClr val="black">
-                <a:alpha val="40000"/>
-              </a:prstClr>
-            </a:outerShdw>
-          </a:effectLst>
-        </p:spPr>
-        <p:txBody>
-          <a:bodyPr rtlCol="0" anchor="ctr"/>
-          <a:lstStyle/>
-          <a:p>
-            <a:pPr marL="0" marR="0" lvl="0" indent="0" algn="ctr" defTabSz="914400" eaLnBrk="1" fontAlgn="auto" latinLnBrk="0" hangingPunct="1">
-              <a:lnSpc>
-                <a:spcPct val="100000"/>
-              </a:lnSpc>
-              <a:spcBef>
-                <a:spcPts val="0"/>
-              </a:spcBef>
-              <a:spcAft>
-                <a:spcPts val="0"/>
-              </a:spcAft>
-              <a:buClrTx/>
-              <a:buSzTx/>
-              <a:buFontTx/>
-              <a:buNone/>
-              <a:tabLst/>
-              <a:defRPr/>
-            </a:pPr>
-            <a:r>
-              <a:rPr kumimoji="0" lang="en-US" sz="1400" b="0" i="0" u="none" strike="noStrike" kern="0" cap="none" spc="0" normalizeH="0" baseline="0" noProof="0" dirty="0">
-                <a:ln>
-                  <a:noFill/>
-                </a:ln>
-                <a:solidFill>
-                  <a:prstClr val="white"/>
-                </a:solidFill>
-                <a:effectLst/>
-                <a:uLnTx/>
-                <a:uFillTx/>
-                <a:latin typeface="Calibri" panose="020F0502020204030204"/>
-                <a:ea typeface="+mn-ea"/>
-                <a:cs typeface="+mn-cs"/>
-              </a:rPr>
-              <a:t>Electricity grid</a:t>
-            </a:r>
-            <a:endParaRPr kumimoji="0" lang="en-GB" sz="1400" b="0" i="0" u="none" strike="noStrike" kern="0" cap="none" spc="0" normalizeH="0" baseline="0" noProof="0" dirty="0">
-              <a:ln>
-                <a:noFill/>
-              </a:ln>
-              <a:solidFill>
-                <a:prstClr val="white"/>
-              </a:solidFill>
-              <a:effectLst/>
-              <a:uLnTx/>
-              <a:uFillTx/>
-              <a:latin typeface="Calibri" panose="020F0502020204030204"/>
-              <a:ea typeface="+mn-ea"/>
-              <a:cs typeface="+mn-cs"/>
-            </a:endParaRPr>
-          </a:p>
-        </p:txBody>
-      </p:sp>
-      <p:cxnSp>
-        <p:nvCxnSpPr>
-          <p:cNvPr id="8" name="Straight Arrow Connector 36">
-            <a:extLst>
-              <a:ext uri="{FF2B5EF4-FFF2-40B4-BE49-F238E27FC236}">
-                <a16:creationId xmlns:a16="http://schemas.microsoft.com/office/drawing/2014/main" id="{D6DBC42B-DE5B-498C-1E53-C13270158927}"/>
-              </a:ext>
-            </a:extLst>
-          </p:cNvPr>
-          <p:cNvCxnSpPr>
-            <a:cxnSpLocks/>
-          </p:cNvCxnSpPr>
-          <p:nvPr/>
-        </p:nvCxnSpPr>
-        <p:spPr>
-          <a:xfrm>
-            <a:off x="4100747" y="4112289"/>
-            <a:ext cx="983560" cy="0"/>
-          </a:xfrm>
-          <a:prstGeom prst="straightConnector1">
-            <a:avLst/>
-          </a:prstGeom>
-          <a:noFill/>
-          <a:ln w="19050" cap="flat" cmpd="sng" algn="ctr">
-            <a:solidFill>
-              <a:srgbClr val="A5A5A5"/>
-            </a:solidFill>
-            <a:prstDash val="solid"/>
-            <a:miter lim="800000"/>
-            <a:tailEnd type="triangle"/>
-          </a:ln>
-          <a:effectLst/>
-        </p:spPr>
-      </p:cxnSp>
-      <p:sp>
-        <p:nvSpPr>
-          <p:cNvPr id="5" name="TextBox 27">
-            <a:extLst>
-              <a:ext uri="{FF2B5EF4-FFF2-40B4-BE49-F238E27FC236}">
-                <a16:creationId xmlns:a16="http://schemas.microsoft.com/office/drawing/2014/main" id="{53D08505-55E5-D8C7-D798-561F679E540B}"/>
-              </a:ext>
-            </a:extLst>
-          </p:cNvPr>
-          <p:cNvSpPr txBox="1"/>
-          <p:nvPr/>
-        </p:nvSpPr>
-        <p:spPr>
-          <a:xfrm>
-            <a:off x="3416976" y="939802"/>
-            <a:ext cx="856765" cy="369332"/>
-          </a:xfrm>
-          <a:prstGeom prst="rect">
-            <a:avLst/>
-          </a:prstGeom>
-          <a:noFill/>
-        </p:spPr>
-        <p:txBody>
-          <a:bodyPr wrap="square" rtlCol="0">
-            <a:spAutoFit/>
-          </a:bodyPr>
-          <a:lstStyle/>
-          <a:p>
-            <a:pPr marL="0" marR="0" lvl="0" indent="0" algn="ctr" defTabSz="914400" eaLnBrk="1" fontAlgn="auto" latinLnBrk="0" hangingPunct="1">
-              <a:lnSpc>
-                <a:spcPct val="100000"/>
-              </a:lnSpc>
-              <a:spcBef>
-                <a:spcPts val="0"/>
-              </a:spcBef>
-              <a:spcAft>
-                <a:spcPts val="0"/>
-              </a:spcAft>
-              <a:buClrTx/>
-              <a:buSzTx/>
-              <a:buFontTx/>
-              <a:buNone/>
-              <a:tabLst/>
-              <a:defRPr/>
-            </a:pPr>
-            <a:r>
-              <a:rPr kumimoji="0" lang="en-US" sz="1800" b="0" i="0" u="none" strike="noStrike" kern="0" cap="none" spc="0" normalizeH="0" baseline="0" noProof="0" dirty="0">
-                <a:ln>
-                  <a:noFill/>
-                </a:ln>
-                <a:solidFill>
-                  <a:prstClr val="black"/>
-                </a:solidFill>
-                <a:effectLst/>
-                <a:uLnTx/>
-                <a:uFillTx/>
-              </a:rPr>
-              <a:t>SE/CO</a:t>
-            </a:r>
-            <a:endParaRPr kumimoji="0" lang="en-GB" sz="1800" b="0" i="0" u="none" strike="noStrike" kern="0" cap="none" spc="0" normalizeH="0" baseline="0" noProof="0" dirty="0">
-              <a:ln>
-                <a:noFill/>
-              </a:ln>
-              <a:solidFill>
-                <a:prstClr val="black"/>
-              </a:solidFill>
-              <a:effectLst/>
-              <a:uLnTx/>
-              <a:uFillTx/>
-            </a:endParaRPr>
-          </a:p>
-        </p:txBody>
-      </p:sp>
-      <p:sp>
-        <p:nvSpPr>
-          <p:cNvPr id="9" name="TextBox 27">
-            <a:extLst>
-              <a:ext uri="{FF2B5EF4-FFF2-40B4-BE49-F238E27FC236}">
-                <a16:creationId xmlns:a16="http://schemas.microsoft.com/office/drawing/2014/main" id="{0BDA1ACE-D659-65AA-0011-527A321F116E}"/>
-              </a:ext>
-            </a:extLst>
-          </p:cNvPr>
-          <p:cNvSpPr txBox="1"/>
-          <p:nvPr/>
-        </p:nvSpPr>
-        <p:spPr>
-          <a:xfrm>
-            <a:off x="3702457" y="1307831"/>
-            <a:ext cx="856765" cy="369332"/>
-          </a:xfrm>
-          <a:prstGeom prst="rect">
-            <a:avLst/>
-          </a:prstGeom>
-          <a:noFill/>
-        </p:spPr>
-        <p:txBody>
-          <a:bodyPr wrap="square" rtlCol="0">
-            <a:spAutoFit/>
-          </a:bodyPr>
-          <a:lstStyle/>
-          <a:p>
-            <a:pPr marL="0" marR="0" lvl="0" indent="0" algn="ctr" defTabSz="914400" eaLnBrk="1" fontAlgn="auto" latinLnBrk="0" hangingPunct="1">
-              <a:lnSpc>
-                <a:spcPct val="100000"/>
-              </a:lnSpc>
-              <a:spcBef>
-                <a:spcPts val="0"/>
-              </a:spcBef>
-              <a:spcAft>
-                <a:spcPts val="0"/>
-              </a:spcAft>
-              <a:buClrTx/>
-              <a:buSzTx/>
-              <a:buFontTx/>
-              <a:buNone/>
-              <a:tabLst/>
-              <a:defRPr/>
-            </a:pPr>
-            <a:r>
-              <a:rPr kumimoji="0" lang="en-US" sz="1800" b="0" i="0" u="none" strike="noStrike" kern="0" cap="none" spc="0" normalizeH="0" baseline="0" noProof="0" dirty="0">
-                <a:ln>
-                  <a:noFill/>
-                </a:ln>
-                <a:solidFill>
-                  <a:prstClr val="black"/>
-                </a:solidFill>
-                <a:effectLst/>
-                <a:uLnTx/>
-                <a:uFillTx/>
-              </a:rPr>
-              <a:t>S</a:t>
-            </a:r>
-            <a:endParaRPr kumimoji="0" lang="en-GB" sz="1800" b="0" i="0" u="none" strike="noStrike" kern="0" cap="none" spc="0" normalizeH="0" baseline="0" noProof="0" dirty="0">
-              <a:ln>
-                <a:noFill/>
-              </a:ln>
-              <a:solidFill>
-                <a:prstClr val="black"/>
-              </a:solidFill>
-              <a:effectLst/>
-              <a:uLnTx/>
-              <a:uFillTx/>
-            </a:endParaRPr>
-          </a:p>
-        </p:txBody>
-      </p:sp>
-      <p:sp>
-        <p:nvSpPr>
-          <p:cNvPr id="10" name="Rectangle: Rounded Corners 20">
-            <a:extLst>
-              <a:ext uri="{FF2B5EF4-FFF2-40B4-BE49-F238E27FC236}">
-                <a16:creationId xmlns:a16="http://schemas.microsoft.com/office/drawing/2014/main" id="{EBA5C0F5-AE6D-5E98-C187-C9D1D2A05DC7}"/>
-              </a:ext>
-            </a:extLst>
-          </p:cNvPr>
-          <p:cNvSpPr/>
-          <p:nvPr/>
-        </p:nvSpPr>
-        <p:spPr>
-          <a:xfrm>
-            <a:off x="4806727" y="1628800"/>
-            <a:ext cx="1244967" cy="648098"/>
-          </a:xfrm>
-          <a:prstGeom prst="roundRect">
-            <a:avLst/>
-          </a:prstGeom>
-          <a:solidFill>
-            <a:srgbClr val="A5A5A5"/>
-          </a:solidFill>
-          <a:ln w="12700" cap="flat" cmpd="sng" algn="ctr">
-            <a:solidFill>
-              <a:srgbClr val="4472C4">
-                <a:shade val="50000"/>
-              </a:srgbClr>
-            </a:solidFill>
-            <a:prstDash val="solid"/>
-            <a:miter lim="800000"/>
-          </a:ln>
-          <a:effectLst>
-            <a:outerShdw blurRad="50800" dist="38100" dir="2700000" algn="tl" rotWithShape="0">
-              <a:prstClr val="black">
-                <a:alpha val="40000"/>
-              </a:prstClr>
-            </a:outerShdw>
-          </a:effectLst>
-        </p:spPr>
-        <p:txBody>
-          <a:bodyPr rtlCol="0" anchor="ctr"/>
-          <a:lstStyle/>
-          <a:p>
-            <a:pPr marL="0" marR="0" lvl="0" indent="0" algn="ctr" defTabSz="914400" eaLnBrk="1" fontAlgn="auto" latinLnBrk="0" hangingPunct="1">
-              <a:lnSpc>
-                <a:spcPct val="100000"/>
-              </a:lnSpc>
-              <a:spcBef>
-                <a:spcPts val="0"/>
-              </a:spcBef>
-              <a:spcAft>
-                <a:spcPts val="0"/>
-              </a:spcAft>
-              <a:buClrTx/>
-              <a:buSzTx/>
-              <a:buFontTx/>
-              <a:buNone/>
-              <a:tabLst/>
-              <a:defRPr/>
-            </a:pPr>
-            <a:r>
-              <a:rPr kumimoji="0" lang="en-US" sz="1400" b="0" i="0" u="none" strike="noStrike" kern="0" cap="none" spc="0" normalizeH="0" baseline="0" noProof="0" dirty="0">
-                <a:ln>
-                  <a:noFill/>
-                </a:ln>
-                <a:solidFill>
-                  <a:prstClr val="white"/>
-                </a:solidFill>
-                <a:effectLst/>
-                <a:uLnTx/>
-                <a:uFillTx/>
-                <a:latin typeface="Calibri" panose="020F0502020204030204"/>
-                <a:ea typeface="+mn-ea"/>
-                <a:cs typeface="+mn-cs"/>
-              </a:rPr>
-              <a:t>Transmission grid</a:t>
-            </a:r>
-            <a:endParaRPr kumimoji="0" lang="en-GB" sz="1400" b="0" i="0" u="none" strike="noStrike" kern="0" cap="none" spc="0" normalizeH="0" baseline="0" noProof="0" dirty="0">
-              <a:ln>
-                <a:noFill/>
-              </a:ln>
-              <a:solidFill>
-                <a:prstClr val="white"/>
-              </a:solidFill>
-              <a:effectLst/>
-              <a:uLnTx/>
-              <a:uFillTx/>
-              <a:latin typeface="Calibri" panose="020F0502020204030204"/>
-              <a:ea typeface="+mn-ea"/>
-              <a:cs typeface="+mn-cs"/>
-            </a:endParaRPr>
-          </a:p>
-        </p:txBody>
-      </p:sp>
-      <p:cxnSp>
-        <p:nvCxnSpPr>
-          <p:cNvPr id="11" name="Straight Arrow Connector 36">
-            <a:extLst>
-              <a:ext uri="{FF2B5EF4-FFF2-40B4-BE49-F238E27FC236}">
-                <a16:creationId xmlns:a16="http://schemas.microsoft.com/office/drawing/2014/main" id="{A09A865D-E3FA-F18A-2E0F-3565F3CBCBE4}"/>
-              </a:ext>
-            </a:extLst>
-          </p:cNvPr>
-          <p:cNvCxnSpPr>
-            <a:cxnSpLocks/>
-          </p:cNvCxnSpPr>
-          <p:nvPr/>
-        </p:nvCxnSpPr>
-        <p:spPr>
-          <a:xfrm>
-            <a:off x="3946467" y="1988840"/>
-            <a:ext cx="860260" cy="0"/>
-          </a:xfrm>
-          <a:prstGeom prst="straightConnector1">
-            <a:avLst/>
-          </a:prstGeom>
-          <a:noFill/>
-          <a:ln w="19050" cap="flat" cmpd="sng" algn="ctr">
-            <a:solidFill>
-              <a:srgbClr val="A5A5A5"/>
-            </a:solidFill>
-            <a:prstDash val="solid"/>
-            <a:miter lim="800000"/>
-            <a:tailEnd type="triangle"/>
-          </a:ln>
-          <a:effectLst/>
-        </p:spPr>
-      </p:cxnSp>
-      <p:cxnSp>
-        <p:nvCxnSpPr>
-          <p:cNvPr id="14" name="Straight Arrow Connector 36">
-            <a:extLst>
-              <a:ext uri="{FF2B5EF4-FFF2-40B4-BE49-F238E27FC236}">
-                <a16:creationId xmlns:a16="http://schemas.microsoft.com/office/drawing/2014/main" id="{F0EF3FF8-6001-BDB3-8345-34AC6A32388D}"/>
-              </a:ext>
-            </a:extLst>
-          </p:cNvPr>
-          <p:cNvCxnSpPr>
-            <a:cxnSpLocks/>
-          </p:cNvCxnSpPr>
-          <p:nvPr/>
-        </p:nvCxnSpPr>
-        <p:spPr>
-          <a:xfrm flipH="1">
-            <a:off x="4100747" y="2060848"/>
-            <a:ext cx="705980" cy="0"/>
-          </a:xfrm>
-          <a:prstGeom prst="straightConnector1">
-            <a:avLst/>
-          </a:prstGeom>
-          <a:noFill/>
-          <a:ln w="19050" cap="flat" cmpd="sng" algn="ctr">
-            <a:solidFill>
-              <a:srgbClr val="A5A5A5"/>
-            </a:solidFill>
-            <a:prstDash val="solid"/>
-            <a:miter lim="800000"/>
-            <a:tailEnd type="triangle"/>
-          </a:ln>
-          <a:effectLst/>
-        </p:spPr>
-      </p:cxnSp>
-      <p:cxnSp>
-        <p:nvCxnSpPr>
-          <p:cNvPr id="17" name="Straight Connector 9">
-            <a:extLst>
-              <a:ext uri="{FF2B5EF4-FFF2-40B4-BE49-F238E27FC236}">
-                <a16:creationId xmlns:a16="http://schemas.microsoft.com/office/drawing/2014/main" id="{B371D0DE-8519-F32C-B36A-9C1E34C93C03}"/>
-              </a:ext>
-            </a:extLst>
-          </p:cNvPr>
-          <p:cNvCxnSpPr>
-            <a:cxnSpLocks/>
-          </p:cNvCxnSpPr>
-          <p:nvPr/>
-        </p:nvCxnSpPr>
-        <p:spPr>
-          <a:xfrm>
-            <a:off x="6729556" y="1724854"/>
-            <a:ext cx="0" cy="4848446"/>
-          </a:xfrm>
-          <a:prstGeom prst="line">
-            <a:avLst/>
-          </a:prstGeom>
-          <a:noFill/>
-          <a:ln w="19050" cap="flat" cmpd="sng" algn="ctr">
-            <a:solidFill>
-              <a:srgbClr val="A5A5A5"/>
-            </a:solidFill>
-            <a:prstDash val="solid"/>
-            <a:miter lim="800000"/>
-          </a:ln>
-          <a:effectLst/>
-        </p:spPr>
-      </p:cxnSp>
-      <p:sp>
-        <p:nvSpPr>
-          <p:cNvPr id="18" name="TextBox 27">
-            <a:extLst>
-              <a:ext uri="{FF2B5EF4-FFF2-40B4-BE49-F238E27FC236}">
-                <a16:creationId xmlns:a16="http://schemas.microsoft.com/office/drawing/2014/main" id="{B7117787-BF4B-9143-DCE5-E6DC754FBFAA}"/>
-              </a:ext>
-            </a:extLst>
-          </p:cNvPr>
-          <p:cNvSpPr txBox="1"/>
-          <p:nvPr/>
-        </p:nvSpPr>
-        <p:spPr>
-          <a:xfrm>
-            <a:off x="6344741" y="1283779"/>
-            <a:ext cx="856765" cy="369332"/>
-          </a:xfrm>
-          <a:prstGeom prst="rect">
-            <a:avLst/>
-          </a:prstGeom>
-          <a:noFill/>
-        </p:spPr>
-        <p:txBody>
-          <a:bodyPr wrap="square" rtlCol="0">
-            <a:spAutoFit/>
-          </a:bodyPr>
-          <a:lstStyle/>
-          <a:p>
-            <a:pPr marL="0" marR="0" lvl="0" indent="0" algn="ctr" defTabSz="914400" eaLnBrk="1" fontAlgn="auto" latinLnBrk="0" hangingPunct="1">
-              <a:lnSpc>
-                <a:spcPct val="100000"/>
-              </a:lnSpc>
-              <a:spcBef>
-                <a:spcPts val="0"/>
-              </a:spcBef>
-              <a:spcAft>
-                <a:spcPts val="0"/>
-              </a:spcAft>
-              <a:buClrTx/>
-              <a:buSzTx/>
-              <a:buFontTx/>
-              <a:buNone/>
-              <a:tabLst/>
-              <a:defRPr/>
-            </a:pPr>
-            <a:r>
-              <a:rPr kumimoji="0" lang="en-US" sz="1800" b="0" i="0" u="none" strike="noStrike" kern="0" cap="none" spc="0" normalizeH="0" baseline="0" noProof="0" dirty="0">
-                <a:ln>
-                  <a:noFill/>
-                </a:ln>
-                <a:solidFill>
-                  <a:prstClr val="black"/>
-                </a:solidFill>
-                <a:effectLst/>
-                <a:uLnTx/>
-                <a:uFillTx/>
-              </a:rPr>
-              <a:t>S</a:t>
-            </a:r>
-            <a:endParaRPr kumimoji="0" lang="en-GB" sz="1800" b="0" i="0" u="none" strike="noStrike" kern="0" cap="none" spc="0" normalizeH="0" baseline="0" noProof="0" dirty="0">
-              <a:ln>
-                <a:noFill/>
-              </a:ln>
-              <a:solidFill>
-                <a:prstClr val="black"/>
-              </a:solidFill>
-              <a:effectLst/>
-              <a:uLnTx/>
-              <a:uFillTx/>
-            </a:endParaRPr>
-          </a:p>
-        </p:txBody>
-      </p:sp>
-      <p:cxnSp>
-        <p:nvCxnSpPr>
-          <p:cNvPr id="19" name="Straight Connector 9">
-            <a:extLst>
-              <a:ext uri="{FF2B5EF4-FFF2-40B4-BE49-F238E27FC236}">
-                <a16:creationId xmlns:a16="http://schemas.microsoft.com/office/drawing/2014/main" id="{C7DF1E0C-0D99-CDF0-F025-4217105E4DF3}"/>
-              </a:ext>
-            </a:extLst>
-          </p:cNvPr>
-          <p:cNvCxnSpPr>
-            <a:cxnSpLocks/>
-          </p:cNvCxnSpPr>
-          <p:nvPr/>
-        </p:nvCxnSpPr>
-        <p:spPr>
-          <a:xfrm>
-            <a:off x="8914135" y="1717765"/>
-            <a:ext cx="0" cy="4848446"/>
-          </a:xfrm>
-          <a:prstGeom prst="line">
-            <a:avLst/>
-          </a:prstGeom>
-          <a:noFill/>
-          <a:ln w="19050" cap="flat" cmpd="sng" algn="ctr">
-            <a:solidFill>
-              <a:srgbClr val="A5A5A5"/>
-            </a:solidFill>
-            <a:prstDash val="solid"/>
-            <a:miter lim="800000"/>
-          </a:ln>
-          <a:effectLst/>
-        </p:spPr>
-      </p:cxnSp>
-      <p:sp>
-        <p:nvSpPr>
-          <p:cNvPr id="20" name="TextBox 27">
-            <a:extLst>
-              <a:ext uri="{FF2B5EF4-FFF2-40B4-BE49-F238E27FC236}">
-                <a16:creationId xmlns:a16="http://schemas.microsoft.com/office/drawing/2014/main" id="{C21B7B3C-6912-87DB-DD85-E4E4C6F084D7}"/>
-              </a:ext>
-            </a:extLst>
-          </p:cNvPr>
-          <p:cNvSpPr txBox="1"/>
-          <p:nvPr/>
-        </p:nvSpPr>
-        <p:spPr>
-          <a:xfrm>
-            <a:off x="8529320" y="1276690"/>
-            <a:ext cx="856765" cy="369332"/>
-          </a:xfrm>
-          <a:prstGeom prst="rect">
-            <a:avLst/>
-          </a:prstGeom>
-          <a:noFill/>
-        </p:spPr>
-        <p:txBody>
-          <a:bodyPr wrap="square" rtlCol="0">
-            <a:spAutoFit/>
-          </a:bodyPr>
-          <a:lstStyle/>
-          <a:p>
-            <a:pPr marL="0" marR="0" lvl="0" indent="0" algn="ctr" defTabSz="914400" eaLnBrk="1" fontAlgn="auto" latinLnBrk="0" hangingPunct="1">
-              <a:lnSpc>
-                <a:spcPct val="100000"/>
-              </a:lnSpc>
-              <a:spcBef>
-                <a:spcPts val="0"/>
-              </a:spcBef>
-              <a:spcAft>
-                <a:spcPts val="0"/>
-              </a:spcAft>
-              <a:buClrTx/>
-              <a:buSzTx/>
-              <a:buFontTx/>
-              <a:buNone/>
-              <a:tabLst/>
-              <a:defRPr/>
-            </a:pPr>
-            <a:r>
-              <a:rPr kumimoji="0" lang="en-US" sz="1800" b="0" i="0" u="none" strike="noStrike" kern="0" cap="none" spc="0" normalizeH="0" baseline="0" noProof="0" dirty="0">
-                <a:ln>
-                  <a:noFill/>
-                </a:ln>
-                <a:solidFill>
-                  <a:prstClr val="black"/>
-                </a:solidFill>
-                <a:effectLst/>
-                <a:uLnTx/>
-                <a:uFillTx/>
-              </a:rPr>
-              <a:t>S</a:t>
-            </a:r>
-            <a:endParaRPr kumimoji="0" lang="en-GB" sz="1800" b="0" i="0" u="none" strike="noStrike" kern="0" cap="none" spc="0" normalizeH="0" baseline="0" noProof="0" dirty="0">
-              <a:ln>
-                <a:noFill/>
-              </a:ln>
-              <a:solidFill>
-                <a:prstClr val="black"/>
-              </a:solidFill>
-              <a:effectLst/>
-              <a:uLnTx/>
-              <a:uFillTx/>
-            </a:endParaRPr>
-          </a:p>
-        </p:txBody>
-      </p:sp>
-      <p:cxnSp>
-        <p:nvCxnSpPr>
-          <p:cNvPr id="21" name="Straight Connector 9">
-            <a:extLst>
-              <a:ext uri="{FF2B5EF4-FFF2-40B4-BE49-F238E27FC236}">
-                <a16:creationId xmlns:a16="http://schemas.microsoft.com/office/drawing/2014/main" id="{3DFC1DD3-A8AF-AB77-6A85-5ED0BED8D793}"/>
-              </a:ext>
-            </a:extLst>
-          </p:cNvPr>
-          <p:cNvCxnSpPr>
-            <a:cxnSpLocks/>
-          </p:cNvCxnSpPr>
-          <p:nvPr/>
-        </p:nvCxnSpPr>
-        <p:spPr>
-          <a:xfrm>
-            <a:off x="11108986" y="1688066"/>
-            <a:ext cx="0" cy="4848446"/>
-          </a:xfrm>
-          <a:prstGeom prst="line">
-            <a:avLst/>
-          </a:prstGeom>
-          <a:noFill/>
-          <a:ln w="19050" cap="flat" cmpd="sng" algn="ctr">
-            <a:solidFill>
-              <a:srgbClr val="A5A5A5"/>
-            </a:solidFill>
-            <a:prstDash val="solid"/>
-            <a:miter lim="800000"/>
-          </a:ln>
-          <a:effectLst/>
-        </p:spPr>
-      </p:cxnSp>
-      <p:sp>
-        <p:nvSpPr>
-          <p:cNvPr id="22" name="TextBox 27">
-            <a:extLst>
-              <a:ext uri="{FF2B5EF4-FFF2-40B4-BE49-F238E27FC236}">
-                <a16:creationId xmlns:a16="http://schemas.microsoft.com/office/drawing/2014/main" id="{8E6876B3-C989-B9BD-4501-F0F216050DF0}"/>
-              </a:ext>
-            </a:extLst>
-          </p:cNvPr>
-          <p:cNvSpPr txBox="1"/>
-          <p:nvPr/>
-        </p:nvSpPr>
-        <p:spPr>
-          <a:xfrm>
-            <a:off x="10724171" y="1246991"/>
-            <a:ext cx="856765" cy="369332"/>
-          </a:xfrm>
-          <a:prstGeom prst="rect">
-            <a:avLst/>
-          </a:prstGeom>
-          <a:noFill/>
-        </p:spPr>
-        <p:txBody>
-          <a:bodyPr wrap="square" rtlCol="0">
-            <a:spAutoFit/>
-          </a:bodyPr>
-          <a:lstStyle/>
-          <a:p>
-            <a:pPr marL="0" marR="0" lvl="0" indent="0" algn="ctr" defTabSz="914400" eaLnBrk="1" fontAlgn="auto" latinLnBrk="0" hangingPunct="1">
-              <a:lnSpc>
-                <a:spcPct val="100000"/>
-              </a:lnSpc>
-              <a:spcBef>
-                <a:spcPts val="0"/>
-              </a:spcBef>
-              <a:spcAft>
-                <a:spcPts val="0"/>
-              </a:spcAft>
-              <a:buClrTx/>
-              <a:buSzTx/>
-              <a:buFontTx/>
-              <a:buNone/>
-              <a:tabLst/>
-              <a:defRPr/>
-            </a:pPr>
-            <a:r>
-              <a:rPr kumimoji="0" lang="en-US" sz="1800" b="0" i="0" u="none" strike="noStrike" kern="0" cap="none" spc="0" normalizeH="0" baseline="0" noProof="0" dirty="0">
-                <a:ln>
-                  <a:noFill/>
-                </a:ln>
-                <a:solidFill>
-                  <a:prstClr val="black"/>
-                </a:solidFill>
-                <a:effectLst/>
-                <a:uLnTx/>
-                <a:uFillTx/>
-              </a:rPr>
-              <a:t>S</a:t>
-            </a:r>
-            <a:endParaRPr kumimoji="0" lang="en-GB" sz="1800" b="0" i="0" u="none" strike="noStrike" kern="0" cap="none" spc="0" normalizeH="0" baseline="0" noProof="0" dirty="0">
-              <a:ln>
-                <a:noFill/>
-              </a:ln>
-              <a:solidFill>
-                <a:prstClr val="black"/>
-              </a:solidFill>
-              <a:effectLst/>
-              <a:uLnTx/>
-              <a:uFillTx/>
-            </a:endParaRPr>
-          </a:p>
-        </p:txBody>
-      </p:sp>
-      <p:sp>
-        <p:nvSpPr>
-          <p:cNvPr id="23" name="TextBox 27">
-            <a:extLst>
-              <a:ext uri="{FF2B5EF4-FFF2-40B4-BE49-F238E27FC236}">
-                <a16:creationId xmlns:a16="http://schemas.microsoft.com/office/drawing/2014/main" id="{1848D667-069F-59AB-3BEF-2FE8956988D2}"/>
-              </a:ext>
-            </a:extLst>
-          </p:cNvPr>
-          <p:cNvSpPr txBox="1"/>
-          <p:nvPr/>
-        </p:nvSpPr>
-        <p:spPr>
-          <a:xfrm>
-            <a:off x="6146087" y="955515"/>
-            <a:ext cx="856765" cy="369332"/>
-          </a:xfrm>
-          <a:prstGeom prst="rect">
-            <a:avLst/>
-          </a:prstGeom>
-          <a:noFill/>
-        </p:spPr>
-        <p:txBody>
-          <a:bodyPr wrap="square" rtlCol="0">
-            <a:spAutoFit/>
-          </a:bodyPr>
-          <a:lstStyle/>
-          <a:p>
-            <a:pPr marL="0" marR="0" lvl="0" indent="0" algn="ctr" defTabSz="914400" eaLnBrk="1" fontAlgn="auto" latinLnBrk="0" hangingPunct="1">
-              <a:lnSpc>
-                <a:spcPct val="100000"/>
-              </a:lnSpc>
-              <a:spcBef>
-                <a:spcPts val="0"/>
-              </a:spcBef>
-              <a:spcAft>
-                <a:spcPts val="0"/>
-              </a:spcAft>
-              <a:buClrTx/>
-              <a:buSzTx/>
-              <a:buFontTx/>
-              <a:buNone/>
-              <a:tabLst/>
-              <a:defRPr/>
-            </a:pPr>
-            <a:r>
-              <a:rPr kumimoji="0" lang="en-US" sz="1800" b="0" i="0" u="none" strike="noStrike" kern="0" cap="none" spc="0" normalizeH="0" baseline="0" noProof="0" dirty="0">
-                <a:ln>
-                  <a:noFill/>
-                </a:ln>
-                <a:solidFill>
-                  <a:prstClr val="black"/>
-                </a:solidFill>
-                <a:effectLst/>
-                <a:uLnTx/>
-                <a:uFillTx/>
-              </a:rPr>
-              <a:t>SE/CO</a:t>
-            </a:r>
-            <a:endParaRPr kumimoji="0" lang="en-GB" sz="1800" b="0" i="0" u="none" strike="noStrike" kern="0" cap="none" spc="0" normalizeH="0" baseline="0" noProof="0" dirty="0">
-              <a:ln>
-                <a:noFill/>
-              </a:ln>
-              <a:solidFill>
-                <a:prstClr val="black"/>
-              </a:solidFill>
-              <a:effectLst/>
-              <a:uLnTx/>
-              <a:uFillTx/>
-            </a:endParaRPr>
-          </a:p>
-        </p:txBody>
-      </p:sp>
-      <p:sp>
-        <p:nvSpPr>
-          <p:cNvPr id="24" name="TextBox 27">
-            <a:extLst>
-              <a:ext uri="{FF2B5EF4-FFF2-40B4-BE49-F238E27FC236}">
-                <a16:creationId xmlns:a16="http://schemas.microsoft.com/office/drawing/2014/main" id="{3D181BBA-532C-98F4-2A1C-380484DA06B2}"/>
-              </a:ext>
-            </a:extLst>
-          </p:cNvPr>
-          <p:cNvSpPr txBox="1"/>
-          <p:nvPr/>
-        </p:nvSpPr>
-        <p:spPr>
-          <a:xfrm>
-            <a:off x="8330666" y="939802"/>
-            <a:ext cx="856765" cy="369332"/>
-          </a:xfrm>
-          <a:prstGeom prst="rect">
-            <a:avLst/>
-          </a:prstGeom>
-          <a:noFill/>
-        </p:spPr>
-        <p:txBody>
-          <a:bodyPr wrap="square" rtlCol="0">
-            <a:spAutoFit/>
-          </a:bodyPr>
-          <a:lstStyle/>
-          <a:p>
-            <a:pPr marL="0" marR="0" lvl="0" indent="0" algn="ctr" defTabSz="914400" eaLnBrk="1" fontAlgn="auto" latinLnBrk="0" hangingPunct="1">
-              <a:lnSpc>
-                <a:spcPct val="100000"/>
-              </a:lnSpc>
-              <a:spcBef>
-                <a:spcPts val="0"/>
-              </a:spcBef>
-              <a:spcAft>
-                <a:spcPts val="0"/>
-              </a:spcAft>
-              <a:buClrTx/>
-              <a:buSzTx/>
-              <a:buFontTx/>
-              <a:buNone/>
-              <a:tabLst/>
-              <a:defRPr/>
-            </a:pPr>
-            <a:r>
-              <a:rPr kumimoji="0" lang="en-US" sz="1800" b="0" i="0" u="none" strike="noStrike" kern="0" cap="none" spc="0" normalizeH="0" baseline="0" noProof="0" dirty="0">
-                <a:ln>
-                  <a:noFill/>
-                </a:ln>
-                <a:solidFill>
-                  <a:prstClr val="black"/>
-                </a:solidFill>
-                <a:effectLst/>
-                <a:uLnTx/>
-                <a:uFillTx/>
-              </a:rPr>
-              <a:t>SE/CO</a:t>
-            </a:r>
-            <a:endParaRPr kumimoji="0" lang="en-GB" sz="1800" b="0" i="0" u="none" strike="noStrike" kern="0" cap="none" spc="0" normalizeH="0" baseline="0" noProof="0" dirty="0">
-              <a:ln>
-                <a:noFill/>
-              </a:ln>
-              <a:solidFill>
-                <a:prstClr val="black"/>
-              </a:solidFill>
-              <a:effectLst/>
-              <a:uLnTx/>
-              <a:uFillTx/>
-            </a:endParaRPr>
-          </a:p>
-        </p:txBody>
-      </p:sp>
-      <p:sp>
-        <p:nvSpPr>
-          <p:cNvPr id="25" name="TextBox 27">
-            <a:extLst>
-              <a:ext uri="{FF2B5EF4-FFF2-40B4-BE49-F238E27FC236}">
-                <a16:creationId xmlns:a16="http://schemas.microsoft.com/office/drawing/2014/main" id="{72395DCC-5A6C-1D2B-DA69-ACEF54E1EE43}"/>
-              </a:ext>
-            </a:extLst>
-          </p:cNvPr>
-          <p:cNvSpPr txBox="1"/>
-          <p:nvPr/>
-        </p:nvSpPr>
-        <p:spPr>
-          <a:xfrm>
-            <a:off x="10478793" y="955515"/>
-            <a:ext cx="856765" cy="369332"/>
-          </a:xfrm>
-          <a:prstGeom prst="rect">
-            <a:avLst/>
-          </a:prstGeom>
-          <a:noFill/>
-        </p:spPr>
-        <p:txBody>
-          <a:bodyPr wrap="square" rtlCol="0">
-            <a:spAutoFit/>
-          </a:bodyPr>
-          <a:lstStyle/>
-          <a:p>
-            <a:pPr marL="0" marR="0" lvl="0" indent="0" algn="ctr" defTabSz="914400" eaLnBrk="1" fontAlgn="auto" latinLnBrk="0" hangingPunct="1">
-              <a:lnSpc>
-                <a:spcPct val="100000"/>
-              </a:lnSpc>
-              <a:spcBef>
-                <a:spcPts val="0"/>
-              </a:spcBef>
-              <a:spcAft>
-                <a:spcPts val="0"/>
-              </a:spcAft>
-              <a:buClrTx/>
-              <a:buSzTx/>
-              <a:buFontTx/>
-              <a:buNone/>
-              <a:tabLst/>
-              <a:defRPr/>
-            </a:pPr>
-            <a:r>
-              <a:rPr kumimoji="0" lang="en-US" sz="1800" b="0" i="0" u="none" strike="noStrike" kern="0" cap="none" spc="0" normalizeH="0" baseline="0" noProof="0" dirty="0">
-                <a:ln>
-                  <a:noFill/>
-                </a:ln>
-                <a:solidFill>
-                  <a:prstClr val="black"/>
-                </a:solidFill>
-                <a:effectLst/>
-                <a:uLnTx/>
-                <a:uFillTx/>
-              </a:rPr>
-              <a:t>SE/CO</a:t>
-            </a:r>
-            <a:endParaRPr kumimoji="0" lang="en-GB" sz="1800" b="0" i="0" u="none" strike="noStrike" kern="0" cap="none" spc="0" normalizeH="0" baseline="0" noProof="0" dirty="0">
-              <a:ln>
-                <a:noFill/>
-              </a:ln>
-              <a:solidFill>
-                <a:prstClr val="black"/>
-              </a:solidFill>
-              <a:effectLst/>
-              <a:uLnTx/>
-              <a:uFillTx/>
-            </a:endParaRPr>
-          </a:p>
-        </p:txBody>
-      </p:sp>
-    </p:spTree>
-    <p:extLst>
-      <p:ext uri="{BB962C8B-B14F-4D97-AF65-F5344CB8AC3E}">
-        <p14:creationId xmlns:p14="http://schemas.microsoft.com/office/powerpoint/2010/main" val="3768136021"/>
       </p:ext>
     </p:extLst>
   </p:cSld>

</xml_diff>